<commit_message>
Updating Coach lecture ppt
Signed-off-by: Harry Kimpel <harrykimpel@hotmail.com>
</commit_message>
<xml_diff>
--- a/073-AgentFrameworkObservabilityWithNewRelic/Coach/Lectures.pptx
+++ b/073-AgentFrameworkObservabilityWithNewRelic/Coach/Lectures.pptx
@@ -5,10 +5,10 @@
     <p:sldMasterId id="2147483986" r:id="rId4"/>
   </p:sldMasterIdLst>
   <p:notesMasterIdLst>
-    <p:notesMasterId r:id="rId31"/>
+    <p:notesMasterId r:id="rId32"/>
   </p:notesMasterIdLst>
   <p:handoutMasterIdLst>
-    <p:handoutMasterId r:id="rId32"/>
+    <p:handoutMasterId r:id="rId33"/>
   </p:handoutMasterIdLst>
   <p:sldIdLst>
     <p:sldId id="3635" r:id="rId5"/>
@@ -18,25 +18,26 @@
     <p:sldId id="3673" r:id="rId9"/>
     <p:sldId id="3660" r:id="rId10"/>
     <p:sldId id="528" r:id="rId11"/>
-    <p:sldId id="3677" r:id="rId12"/>
-    <p:sldId id="3678" r:id="rId13"/>
-    <p:sldId id="3679" r:id="rId14"/>
-    <p:sldId id="3680" r:id="rId15"/>
-    <p:sldId id="3681" r:id="rId16"/>
-    <p:sldId id="3682" r:id="rId17"/>
-    <p:sldId id="3683" r:id="rId18"/>
-    <p:sldId id="3684" r:id="rId19"/>
-    <p:sldId id="3685" r:id="rId20"/>
-    <p:sldId id="3686" r:id="rId21"/>
-    <p:sldId id="3687" r:id="rId22"/>
-    <p:sldId id="3688" r:id="rId23"/>
-    <p:sldId id="3689" r:id="rId24"/>
-    <p:sldId id="3690" r:id="rId25"/>
-    <p:sldId id="3691" r:id="rId26"/>
-    <p:sldId id="3692" r:id="rId27"/>
-    <p:sldId id="3693" r:id="rId28"/>
-    <p:sldId id="3694" r:id="rId29"/>
-    <p:sldId id="3663" r:id="rId30"/>
+    <p:sldId id="3695" r:id="rId12"/>
+    <p:sldId id="3677" r:id="rId13"/>
+    <p:sldId id="3678" r:id="rId14"/>
+    <p:sldId id="3679" r:id="rId15"/>
+    <p:sldId id="3680" r:id="rId16"/>
+    <p:sldId id="3681" r:id="rId17"/>
+    <p:sldId id="3682" r:id="rId18"/>
+    <p:sldId id="3683" r:id="rId19"/>
+    <p:sldId id="3684" r:id="rId20"/>
+    <p:sldId id="3685" r:id="rId21"/>
+    <p:sldId id="3686" r:id="rId22"/>
+    <p:sldId id="3687" r:id="rId23"/>
+    <p:sldId id="3688" r:id="rId24"/>
+    <p:sldId id="3689" r:id="rId25"/>
+    <p:sldId id="3690" r:id="rId26"/>
+    <p:sldId id="3691" r:id="rId27"/>
+    <p:sldId id="3692" r:id="rId28"/>
+    <p:sldId id="3693" r:id="rId29"/>
+    <p:sldId id="3694" r:id="rId30"/>
+    <p:sldId id="3663" r:id="rId31"/>
   </p:sldIdLst>
   <p:sldSz cx="12192000" cy="6858000"/>
   <p:notesSz cx="6858000" cy="9144000"/>
@@ -1194,7 +1195,7 @@
           <a:p>
             <a:fld id="{D2F29697-4A6D-AC4B-B035-E737BE26C24F}" type="datetimeFigureOut">
               <a:rPr lang="en-US" smtClean="0"/>
-              <a:t>2/4/26</a:t>
+              <a:t>3/24/26</a:t>
             </a:fld>
             <a:endParaRPr lang="en-US"/>
           </a:p>
@@ -1359,7 +1360,7 @@
           <a:p>
             <a:fld id="{3B795838-E26F-BF4F-AF40-5695E293B9BE}" type="datetimeFigureOut">
               <a:rPr lang="en-US" smtClean="0"/>
-              <a:t>2/4/26</a:t>
+              <a:t>3/24/26</a:t>
             </a:fld>
             <a:endParaRPr lang="en-US"/>
           </a:p>
@@ -1805,6 +1806,207 @@
         <p:cNvPr id="1" name="">
           <a:extLst>
             <a:ext uri="{FF2B5EF4-FFF2-40B4-BE49-F238E27FC236}">
+              <a16:creationId xmlns:a16="http://schemas.microsoft.com/office/drawing/2014/main" id="{E9544A43-CA26-FD5B-60E9-4A4E2234D37D}"/>
+            </a:ext>
+          </a:extLst>
+        </p:cNvPr>
+        <p:cNvGrpSpPr/>
+        <p:nvPr/>
+      </p:nvGrpSpPr>
+      <p:grpSpPr>
+        <a:xfrm>
+          <a:off x="0" y="0"/>
+          <a:ext cx="0" cy="0"/>
+          <a:chOff x="0" y="0"/>
+          <a:chExt cx="0" cy="0"/>
+        </a:xfrm>
+      </p:grpSpPr>
+      <p:sp>
+        <p:nvSpPr>
+          <p:cNvPr id="2" name="Slide Image Placeholder 1">
+            <a:extLst>
+              <a:ext uri="{FF2B5EF4-FFF2-40B4-BE49-F238E27FC236}">
+                <a16:creationId xmlns:a16="http://schemas.microsoft.com/office/drawing/2014/main" id="{7C4BB357-40A9-F43B-F393-E5E226AE7CB9}"/>
+              </a:ext>
+            </a:extLst>
+          </p:cNvPr>
+          <p:cNvSpPr>
+            <a:spLocks noGrp="1" noRot="1" noChangeAspect="1"/>
+          </p:cNvSpPr>
+          <p:nvPr>
+            <p:ph type="sldImg"/>
+          </p:nvPr>
+        </p:nvSpPr>
+        <p:spPr/>
+      </p:sp>
+      <p:sp>
+        <p:nvSpPr>
+          <p:cNvPr id="3" name="Notes Placeholder 2">
+            <a:extLst>
+              <a:ext uri="{FF2B5EF4-FFF2-40B4-BE49-F238E27FC236}">
+                <a16:creationId xmlns:a16="http://schemas.microsoft.com/office/drawing/2014/main" id="{5BB54B11-589E-C1A1-3D4C-9C3CAC2D038C}"/>
+              </a:ext>
+            </a:extLst>
+          </p:cNvPr>
+          <p:cNvSpPr>
+            <a:spLocks noGrp="1"/>
+          </p:cNvSpPr>
+          <p:nvPr>
+            <p:ph type="body" idx="1"/>
+          </p:nvPr>
+        </p:nvSpPr>
+        <p:spPr/>
+        <p:txBody>
+          <a:bodyPr/>
+          <a:lstStyle/>
+          <a:p>
+            <a:r>
+              <a:rPr lang="en-US" dirty="0"/>
+              <a:t>Template for a lecture slide with bullets (if you need them).</a:t>
+            </a:r>
+          </a:p>
+          <a:p>
+            <a:endParaRPr lang="en-US" dirty="0"/>
+          </a:p>
+          <a:p>
+            <a:r>
+              <a:rPr lang="en-US" dirty="0"/>
+              <a:t>Try to NOT use bullet lists in your presentation.  </a:t>
+            </a:r>
+          </a:p>
+          <a:p>
+            <a:r>
+              <a:rPr lang="en-US" dirty="0"/>
+              <a:t>Diagrams, puppy pictures, </a:t>
+            </a:r>
+            <a:r>
+              <a:rPr lang="en-US" dirty="0" err="1"/>
+              <a:t>etc</a:t>
+            </a:r>
+            <a:r>
+              <a:rPr lang="en-US" dirty="0"/>
+              <a:t> are always better. </a:t>
+            </a:r>
+            <a:r>
+              <a:rPr lang="en-US" dirty="0">
+                <a:sym typeface="Wingdings" panose="05000000000000000000" pitchFamily="2" charset="2"/>
+              </a:rPr>
+              <a:t></a:t>
+            </a:r>
+            <a:endParaRPr lang="en-US" dirty="0"/>
+          </a:p>
+        </p:txBody>
+      </p:sp>
+      <p:sp>
+        <p:nvSpPr>
+          <p:cNvPr id="4" name="Slide Number Placeholder 3">
+            <a:extLst>
+              <a:ext uri="{FF2B5EF4-FFF2-40B4-BE49-F238E27FC236}">
+                <a16:creationId xmlns:a16="http://schemas.microsoft.com/office/drawing/2014/main" id="{EAA2C23F-350C-1009-F9BB-3FA904F734A6}"/>
+              </a:ext>
+            </a:extLst>
+          </p:cNvPr>
+          <p:cNvSpPr>
+            <a:spLocks noGrp="1"/>
+          </p:cNvSpPr>
+          <p:nvPr>
+            <p:ph type="sldNum" sz="quarter" idx="5"/>
+          </p:nvPr>
+        </p:nvSpPr>
+        <p:spPr/>
+        <p:txBody>
+          <a:bodyPr/>
+          <a:lstStyle/>
+          <a:p>
+            <a:pPr marL="0" marR="0" lvl="0" indent="0" algn="r" defTabSz="914400" rtl="0" eaLnBrk="1" fontAlgn="auto" latinLnBrk="0" hangingPunct="1">
+              <a:lnSpc>
+                <a:spcPct val="100000"/>
+              </a:lnSpc>
+              <a:spcBef>
+                <a:spcPts val="0"/>
+              </a:spcBef>
+              <a:spcAft>
+                <a:spcPts val="0"/>
+              </a:spcAft>
+              <a:buClrTx/>
+              <a:buSzTx/>
+              <a:buFontTx/>
+              <a:buNone/>
+              <a:tabLst/>
+              <a:defRPr/>
+            </a:pPr>
+            <a:fld id="{72A19410-49C3-46C5-A633-999FD8C4418C}" type="slidenum">
+              <a:rPr kumimoji="0" lang="en-US" sz="1200" b="0" i="0" u="none" strike="noStrike" kern="1200" cap="none" spc="0" normalizeH="0" baseline="0" noProof="0" smtClean="0">
+                <a:ln>
+                  <a:noFill/>
+                </a:ln>
+                <a:solidFill>
+                  <a:prstClr val="black"/>
+                </a:solidFill>
+                <a:effectLst/>
+                <a:uLnTx/>
+                <a:uFillTx/>
+                <a:latin typeface="Calibri" panose="020F0502020204030204"/>
+                <a:ea typeface="+mn-ea"/>
+                <a:cs typeface="+mn-cs"/>
+              </a:rPr>
+              <a:pPr marL="0" marR="0" lvl="0" indent="0" algn="r" defTabSz="914400" rtl="0" eaLnBrk="1" fontAlgn="auto" latinLnBrk="0" hangingPunct="1">
+                <a:lnSpc>
+                  <a:spcPct val="100000"/>
+                </a:lnSpc>
+                <a:spcBef>
+                  <a:spcPts val="0"/>
+                </a:spcBef>
+                <a:spcAft>
+                  <a:spcPts val="0"/>
+                </a:spcAft>
+                <a:buClrTx/>
+                <a:buSzTx/>
+                <a:buFontTx/>
+                <a:buNone/>
+                <a:tabLst/>
+                <a:defRPr/>
+              </a:pPr>
+              <a:t>13</a:t>
+            </a:fld>
+            <a:endParaRPr kumimoji="0" lang="en-US" sz="1200" b="0" i="0" u="none" strike="noStrike" kern="1200" cap="none" spc="0" normalizeH="0" baseline="0" noProof="0">
+              <a:ln>
+                <a:noFill/>
+              </a:ln>
+              <a:solidFill>
+                <a:prstClr val="black"/>
+              </a:solidFill>
+              <a:effectLst/>
+              <a:uLnTx/>
+              <a:uFillTx/>
+              <a:latin typeface="Calibri" panose="020F0502020204030204"/>
+              <a:ea typeface="+mn-ea"/>
+              <a:cs typeface="+mn-cs"/>
+            </a:endParaRPr>
+          </a:p>
+        </p:txBody>
+      </p:sp>
+    </p:spTree>
+    <p:extLst>
+      <p:ext uri="{BB962C8B-B14F-4D97-AF65-F5344CB8AC3E}">
+        <p14:creationId xmlns:p14="http://schemas.microsoft.com/office/powerpoint/2010/main" val="42463"/>
+      </p:ext>
+    </p:extLst>
+  </p:cSld>
+  <p:clrMapOvr>
+    <a:masterClrMapping/>
+  </p:clrMapOvr>
+</p:notes>
+</file>
+
+<file path=ppt/notesSlides/notesSlide11.xml><?xml version="1.0" encoding="utf-8"?>
+<p:notes xmlns:a="http://schemas.openxmlformats.org/drawingml/2006/main" xmlns:r="http://schemas.openxmlformats.org/officeDocument/2006/relationships" xmlns:p="http://schemas.openxmlformats.org/presentationml/2006/main">
+  <p:cSld>
+    <p:spTree>
+      <p:nvGrpSpPr>
+        <p:cNvPr id="1" name="">
+          <a:extLst>
+            <a:ext uri="{FF2B5EF4-FFF2-40B4-BE49-F238E27FC236}">
               <a16:creationId xmlns:a16="http://schemas.microsoft.com/office/drawing/2014/main" id="{5E9ABEE9-828E-03B0-303F-3043D7204CF1}"/>
             </a:ext>
           </a:extLst>
@@ -1942,7 +2144,7 @@
                 <a:tabLst/>
                 <a:defRPr/>
               </a:pPr>
-              <a:t>13</a:t>
+              <a:t>14</a:t>
             </a:fld>
             <a:endParaRPr kumimoji="0" lang="en-US" sz="1200" b="0" i="0" u="none" strike="noStrike" kern="1200" cap="none" spc="0" normalizeH="0" baseline="0" noProof="0">
               <a:ln>
@@ -1974,7 +2176,7 @@
 </p:notes>
 </file>
 
-<file path=ppt/notesSlides/notesSlide11.xml><?xml version="1.0" encoding="utf-8"?>
+<file path=ppt/notesSlides/notesSlide12.xml><?xml version="1.0" encoding="utf-8"?>
 <p:notes xmlns:a="http://schemas.openxmlformats.org/drawingml/2006/main" xmlns:r="http://schemas.openxmlformats.org/officeDocument/2006/relationships" xmlns:p="http://schemas.openxmlformats.org/presentationml/2006/main">
   <p:cSld>
     <p:spTree>
@@ -2143,7 +2345,7 @@
                 <a:tabLst/>
                 <a:defRPr/>
               </a:pPr>
-              <a:t>15</a:t>
+              <a:t>16</a:t>
             </a:fld>
             <a:endParaRPr kumimoji="0" lang="en-US" sz="1200" b="0" i="0" u="none" strike="noStrike" kern="1200" cap="none" spc="0" normalizeH="0" baseline="0" noProof="0">
               <a:ln>
@@ -2175,7 +2377,7 @@
 </p:notes>
 </file>
 
-<file path=ppt/notesSlides/notesSlide12.xml><?xml version="1.0" encoding="utf-8"?>
+<file path=ppt/notesSlides/notesSlide13.xml><?xml version="1.0" encoding="utf-8"?>
 <p:notes xmlns:a="http://schemas.openxmlformats.org/drawingml/2006/main" xmlns:r="http://schemas.openxmlformats.org/officeDocument/2006/relationships" xmlns:p="http://schemas.openxmlformats.org/presentationml/2006/main">
   <p:cSld>
     <p:spTree>
@@ -2320,7 +2522,7 @@
                 <a:tabLst/>
                 <a:defRPr/>
               </a:pPr>
-              <a:t>16</a:t>
+              <a:t>17</a:t>
             </a:fld>
             <a:endParaRPr kumimoji="0" lang="en-US" sz="1200" b="0" i="0" u="none" strike="noStrike" kern="1200" cap="none" spc="0" normalizeH="0" baseline="0" noProof="0">
               <a:ln>
@@ -2352,7 +2554,7 @@
 </p:notes>
 </file>
 
-<file path=ppt/notesSlides/notesSlide13.xml><?xml version="1.0" encoding="utf-8"?>
+<file path=ppt/notesSlides/notesSlide14.xml><?xml version="1.0" encoding="utf-8"?>
 <p:notes xmlns:a="http://schemas.openxmlformats.org/drawingml/2006/main" xmlns:r="http://schemas.openxmlformats.org/officeDocument/2006/relationships" xmlns:p="http://schemas.openxmlformats.org/presentationml/2006/main">
   <p:cSld>
     <p:spTree>
@@ -2521,7 +2723,7 @@
                 <a:tabLst/>
                 <a:defRPr/>
               </a:pPr>
-              <a:t>18</a:t>
+              <a:t>19</a:t>
             </a:fld>
             <a:endParaRPr kumimoji="0" lang="en-US" sz="1200" b="0" i="0" u="none" strike="noStrike" kern="1200" cap="none" spc="0" normalizeH="0" baseline="0" noProof="0">
               <a:ln>
@@ -2553,7 +2755,7 @@
 </p:notes>
 </file>
 
-<file path=ppt/notesSlides/notesSlide14.xml><?xml version="1.0" encoding="utf-8"?>
+<file path=ppt/notesSlides/notesSlide15.xml><?xml version="1.0" encoding="utf-8"?>
 <p:notes xmlns:a="http://schemas.openxmlformats.org/drawingml/2006/main" xmlns:r="http://schemas.openxmlformats.org/officeDocument/2006/relationships" xmlns:p="http://schemas.openxmlformats.org/presentationml/2006/main">
   <p:cSld>
     <p:spTree>
@@ -2698,7 +2900,7 @@
                 <a:tabLst/>
                 <a:defRPr/>
               </a:pPr>
-              <a:t>19</a:t>
+              <a:t>20</a:t>
             </a:fld>
             <a:endParaRPr kumimoji="0" lang="en-US" sz="1200" b="0" i="0" u="none" strike="noStrike" kern="1200" cap="none" spc="0" normalizeH="0" baseline="0" noProof="0">
               <a:ln>
@@ -2730,7 +2932,7 @@
 </p:notes>
 </file>
 
-<file path=ppt/notesSlides/notesSlide15.xml><?xml version="1.0" encoding="utf-8"?>
+<file path=ppt/notesSlides/notesSlide16.xml><?xml version="1.0" encoding="utf-8"?>
 <p:notes xmlns:a="http://schemas.openxmlformats.org/drawingml/2006/main" xmlns:r="http://schemas.openxmlformats.org/officeDocument/2006/relationships" xmlns:p="http://schemas.openxmlformats.org/presentationml/2006/main">
   <p:cSld>
     <p:spTree>
@@ -2899,7 +3101,7 @@
                 <a:tabLst/>
                 <a:defRPr/>
               </a:pPr>
-              <a:t>21</a:t>
+              <a:t>22</a:t>
             </a:fld>
             <a:endParaRPr kumimoji="0" lang="en-US" sz="1200" b="0" i="0" u="none" strike="noStrike" kern="1200" cap="none" spc="0" normalizeH="0" baseline="0" noProof="0">
               <a:ln>
@@ -2931,7 +3133,7 @@
 </p:notes>
 </file>
 
-<file path=ppt/notesSlides/notesSlide16.xml><?xml version="1.0" encoding="utf-8"?>
+<file path=ppt/notesSlides/notesSlide17.xml><?xml version="1.0" encoding="utf-8"?>
 <p:notes xmlns:a="http://schemas.openxmlformats.org/drawingml/2006/main" xmlns:r="http://schemas.openxmlformats.org/officeDocument/2006/relationships" xmlns:p="http://schemas.openxmlformats.org/presentationml/2006/main">
   <p:cSld>
     <p:spTree>
@@ -3076,7 +3278,7 @@
                 <a:tabLst/>
                 <a:defRPr/>
               </a:pPr>
-              <a:t>22</a:t>
+              <a:t>23</a:t>
             </a:fld>
             <a:endParaRPr kumimoji="0" lang="en-US" sz="1200" b="0" i="0" u="none" strike="noStrike" kern="1200" cap="none" spc="0" normalizeH="0" baseline="0" noProof="0">
               <a:ln>
@@ -3108,7 +3310,7 @@
 </p:notes>
 </file>
 
-<file path=ppt/notesSlides/notesSlide17.xml><?xml version="1.0" encoding="utf-8"?>
+<file path=ppt/notesSlides/notesSlide18.xml><?xml version="1.0" encoding="utf-8"?>
 <p:notes xmlns:a="http://schemas.openxmlformats.org/drawingml/2006/main" xmlns:r="http://schemas.openxmlformats.org/officeDocument/2006/relationships" xmlns:p="http://schemas.openxmlformats.org/presentationml/2006/main">
   <p:cSld>
     <p:spTree>
@@ -3277,7 +3479,7 @@
                 <a:tabLst/>
                 <a:defRPr/>
               </a:pPr>
-              <a:t>24</a:t>
+              <a:t>25</a:t>
             </a:fld>
             <a:endParaRPr kumimoji="0" lang="en-US" sz="1200" b="0" i="0" u="none" strike="noStrike" kern="1200" cap="none" spc="0" normalizeH="0" baseline="0" noProof="0">
               <a:ln>
@@ -3309,7 +3511,7 @@
 </p:notes>
 </file>
 
-<file path=ppt/notesSlides/notesSlide18.xml><?xml version="1.0" encoding="utf-8"?>
+<file path=ppt/notesSlides/notesSlide19.xml><?xml version="1.0" encoding="utf-8"?>
 <p:notes xmlns:a="http://schemas.openxmlformats.org/drawingml/2006/main" xmlns:r="http://schemas.openxmlformats.org/officeDocument/2006/relationships" xmlns:p="http://schemas.openxmlformats.org/presentationml/2006/main">
   <p:cSld>
     <p:spTree>
@@ -3454,7 +3656,7 @@
                 <a:tabLst/>
                 <a:defRPr/>
               </a:pPr>
-              <a:t>25</a:t>
+              <a:t>26</a:t>
             </a:fld>
             <a:endParaRPr kumimoji="0" lang="en-US" sz="1200" b="0" i="0" u="none" strike="noStrike" kern="1200" cap="none" spc="0" normalizeH="0" baseline="0" noProof="0">
               <a:ln>
@@ -3477,159 +3679,6 @@
     <p:extLst>
       <p:ext uri="{BB962C8B-B14F-4D97-AF65-F5344CB8AC3E}">
         <p14:creationId xmlns:p14="http://schemas.microsoft.com/office/powerpoint/2010/main" val="2266862844"/>
-      </p:ext>
-    </p:extLst>
-  </p:cSld>
-  <p:clrMapOvr>
-    <a:masterClrMapping/>
-  </p:clrMapOvr>
-</p:notes>
-</file>
-
-<file path=ppt/notesSlides/notesSlide19.xml><?xml version="1.0" encoding="utf-8"?>
-<p:notes xmlns:a="http://schemas.openxmlformats.org/drawingml/2006/main" xmlns:r="http://schemas.openxmlformats.org/officeDocument/2006/relationships" xmlns:p="http://schemas.openxmlformats.org/presentationml/2006/main">
-  <p:cSld>
-    <p:spTree>
-      <p:nvGrpSpPr>
-        <p:cNvPr id="1" name=""/>
-        <p:cNvGrpSpPr/>
-        <p:nvPr/>
-      </p:nvGrpSpPr>
-      <p:grpSpPr>
-        <a:xfrm>
-          <a:off x="0" y="0"/>
-          <a:ext cx="0" cy="0"/>
-          <a:chOff x="0" y="0"/>
-          <a:chExt cx="0" cy="0"/>
-        </a:xfrm>
-      </p:grpSpPr>
-      <p:sp>
-        <p:nvSpPr>
-          <p:cNvPr id="2" name="Slide Image Placeholder 1"/>
-          <p:cNvSpPr>
-            <a:spLocks noGrp="1" noRot="1" noChangeAspect="1"/>
-          </p:cNvSpPr>
-          <p:nvPr>
-            <p:ph type="sldImg"/>
-          </p:nvPr>
-        </p:nvSpPr>
-        <p:spPr/>
-      </p:sp>
-      <p:sp>
-        <p:nvSpPr>
-          <p:cNvPr id="3" name="Notes Placeholder 2"/>
-          <p:cNvSpPr>
-            <a:spLocks noGrp="1"/>
-          </p:cNvSpPr>
-          <p:nvPr>
-            <p:ph type="body" idx="1"/>
-          </p:nvPr>
-        </p:nvSpPr>
-        <p:spPr/>
-        <p:txBody>
-          <a:bodyPr/>
-          <a:lstStyle/>
-          <a:p>
-            <a:r>
-              <a:rPr lang="en-US" dirty="0"/>
-              <a:t>Thank students for attending and share the link to the What The Hack website with them.</a:t>
-            </a:r>
-          </a:p>
-          <a:p>
-            <a:endParaRPr lang="en-US" dirty="0"/>
-          </a:p>
-          <a:p>
-            <a:endParaRPr lang="en-US" dirty="0"/>
-          </a:p>
-        </p:txBody>
-      </p:sp>
-      <p:sp>
-        <p:nvSpPr>
-          <p:cNvPr id="4" name="Slide Number Placeholder 3"/>
-          <p:cNvSpPr>
-            <a:spLocks noGrp="1"/>
-          </p:cNvSpPr>
-          <p:nvPr>
-            <p:ph type="sldNum" sz="quarter" idx="10"/>
-          </p:nvPr>
-        </p:nvSpPr>
-        <p:spPr/>
-        <p:txBody>
-          <a:bodyPr/>
-          <a:lstStyle/>
-          <a:p>
-            <a:pPr marL="0" marR="0" lvl="0" indent="0" algn="r" defTabSz="914400" rtl="0" eaLnBrk="1" fontAlgn="auto" latinLnBrk="0" hangingPunct="1">
-              <a:lnSpc>
-                <a:spcPct val="100000"/>
-              </a:lnSpc>
-              <a:spcBef>
-                <a:spcPts val="0"/>
-              </a:spcBef>
-              <a:spcAft>
-                <a:spcPts val="0"/>
-              </a:spcAft>
-              <a:buClrTx/>
-              <a:buSzTx/>
-              <a:buFontTx/>
-              <a:buNone/>
-              <a:tabLst/>
-              <a:defRPr/>
-            </a:pPr>
-            <a:fld id="{315375D1-61FB-3243-8074-59CD809395A7}" type="slidenum">
-              <a:rPr kumimoji="0" lang="en-US" sz="1200" b="0" i="0" u="none" strike="noStrike" kern="1200" cap="none" spc="0" normalizeH="0" baseline="0" noProof="0" smtClean="0">
-                <a:ln>
-                  <a:noFill/>
-                </a:ln>
-                <a:solidFill>
-                  <a:prstClr val="black"/>
-                </a:solidFill>
-                <a:effectLst/>
-                <a:uLnTx/>
-                <a:uFillTx/>
-                <a:latin typeface="Calibri" panose="020F0502020204030204"/>
-                <a:ea typeface="+mn-ea"/>
-                <a:cs typeface="+mn-cs"/>
-              </a:rPr>
-              <a:pPr marL="0" marR="0" lvl="0" indent="0" algn="r" defTabSz="914400" rtl="0" eaLnBrk="1" fontAlgn="auto" latinLnBrk="0" hangingPunct="1">
-                <a:lnSpc>
-                  <a:spcPct val="100000"/>
-                </a:lnSpc>
-                <a:spcBef>
-                  <a:spcPts val="0"/>
-                </a:spcBef>
-                <a:spcAft>
-                  <a:spcPts val="0"/>
-                </a:spcAft>
-                <a:buClrTx/>
-                <a:buSzTx/>
-                <a:buFontTx/>
-                <a:buNone/>
-                <a:tabLst/>
-                <a:defRPr/>
-              </a:pPr>
-              <a:t>26</a:t>
-            </a:fld>
-            <a:endParaRPr kumimoji="0" lang="en-US" sz="1200" b="0" i="0" u="none" strike="noStrike" kern="1200" cap="none" spc="0" normalizeH="0" baseline="0" noProof="0" dirty="0">
-              <a:ln>
-                <a:noFill/>
-              </a:ln>
-              <a:solidFill>
-                <a:prstClr val="black"/>
-              </a:solidFill>
-              <a:effectLst/>
-              <a:uLnTx/>
-              <a:uFillTx/>
-              <a:latin typeface="Calibri" panose="020F0502020204030204"/>
-              <a:ea typeface="+mn-ea"/>
-              <a:cs typeface="+mn-cs"/>
-            </a:endParaRPr>
-          </a:p>
-        </p:txBody>
-      </p:sp>
-    </p:spTree>
-    <p:extLst>
-      <p:ext uri="{BB962C8B-B14F-4D97-AF65-F5344CB8AC3E}">
-        <p14:creationId xmlns:p14="http://schemas.microsoft.com/office/powerpoint/2010/main" val="1917725678"/>
       </p:ext>
     </p:extLst>
   </p:cSld>
@@ -3830,6 +3879,159 @@
 </p:notes>
 </file>
 
+<file path=ppt/notesSlides/notesSlide20.xml><?xml version="1.0" encoding="utf-8"?>
+<p:notes xmlns:a="http://schemas.openxmlformats.org/drawingml/2006/main" xmlns:r="http://schemas.openxmlformats.org/officeDocument/2006/relationships" xmlns:p="http://schemas.openxmlformats.org/presentationml/2006/main">
+  <p:cSld>
+    <p:spTree>
+      <p:nvGrpSpPr>
+        <p:cNvPr id="1" name=""/>
+        <p:cNvGrpSpPr/>
+        <p:nvPr/>
+      </p:nvGrpSpPr>
+      <p:grpSpPr>
+        <a:xfrm>
+          <a:off x="0" y="0"/>
+          <a:ext cx="0" cy="0"/>
+          <a:chOff x="0" y="0"/>
+          <a:chExt cx="0" cy="0"/>
+        </a:xfrm>
+      </p:grpSpPr>
+      <p:sp>
+        <p:nvSpPr>
+          <p:cNvPr id="2" name="Slide Image Placeholder 1"/>
+          <p:cNvSpPr>
+            <a:spLocks noGrp="1" noRot="1" noChangeAspect="1"/>
+          </p:cNvSpPr>
+          <p:nvPr>
+            <p:ph type="sldImg"/>
+          </p:nvPr>
+        </p:nvSpPr>
+        <p:spPr/>
+      </p:sp>
+      <p:sp>
+        <p:nvSpPr>
+          <p:cNvPr id="3" name="Notes Placeholder 2"/>
+          <p:cNvSpPr>
+            <a:spLocks noGrp="1"/>
+          </p:cNvSpPr>
+          <p:nvPr>
+            <p:ph type="body" idx="1"/>
+          </p:nvPr>
+        </p:nvSpPr>
+        <p:spPr/>
+        <p:txBody>
+          <a:bodyPr/>
+          <a:lstStyle/>
+          <a:p>
+            <a:r>
+              <a:rPr lang="en-US" dirty="0"/>
+              <a:t>Thank students for attending and share the link to the What The Hack website with them.</a:t>
+            </a:r>
+          </a:p>
+          <a:p>
+            <a:endParaRPr lang="en-US" dirty="0"/>
+          </a:p>
+          <a:p>
+            <a:endParaRPr lang="en-US" dirty="0"/>
+          </a:p>
+        </p:txBody>
+      </p:sp>
+      <p:sp>
+        <p:nvSpPr>
+          <p:cNvPr id="4" name="Slide Number Placeholder 3"/>
+          <p:cNvSpPr>
+            <a:spLocks noGrp="1"/>
+          </p:cNvSpPr>
+          <p:nvPr>
+            <p:ph type="sldNum" sz="quarter" idx="10"/>
+          </p:nvPr>
+        </p:nvSpPr>
+        <p:spPr/>
+        <p:txBody>
+          <a:bodyPr/>
+          <a:lstStyle/>
+          <a:p>
+            <a:pPr marL="0" marR="0" lvl="0" indent="0" algn="r" defTabSz="914400" rtl="0" eaLnBrk="1" fontAlgn="auto" latinLnBrk="0" hangingPunct="1">
+              <a:lnSpc>
+                <a:spcPct val="100000"/>
+              </a:lnSpc>
+              <a:spcBef>
+                <a:spcPts val="0"/>
+              </a:spcBef>
+              <a:spcAft>
+                <a:spcPts val="0"/>
+              </a:spcAft>
+              <a:buClrTx/>
+              <a:buSzTx/>
+              <a:buFontTx/>
+              <a:buNone/>
+              <a:tabLst/>
+              <a:defRPr/>
+            </a:pPr>
+            <a:fld id="{315375D1-61FB-3243-8074-59CD809395A7}" type="slidenum">
+              <a:rPr kumimoji="0" lang="en-US" sz="1200" b="0" i="0" u="none" strike="noStrike" kern="1200" cap="none" spc="0" normalizeH="0" baseline="0" noProof="0" smtClean="0">
+                <a:ln>
+                  <a:noFill/>
+                </a:ln>
+                <a:solidFill>
+                  <a:prstClr val="black"/>
+                </a:solidFill>
+                <a:effectLst/>
+                <a:uLnTx/>
+                <a:uFillTx/>
+                <a:latin typeface="Calibri" panose="020F0502020204030204"/>
+                <a:ea typeface="+mn-ea"/>
+                <a:cs typeface="+mn-cs"/>
+              </a:rPr>
+              <a:pPr marL="0" marR="0" lvl="0" indent="0" algn="r" defTabSz="914400" rtl="0" eaLnBrk="1" fontAlgn="auto" latinLnBrk="0" hangingPunct="1">
+                <a:lnSpc>
+                  <a:spcPct val="100000"/>
+                </a:lnSpc>
+                <a:spcBef>
+                  <a:spcPts val="0"/>
+                </a:spcBef>
+                <a:spcAft>
+                  <a:spcPts val="0"/>
+                </a:spcAft>
+                <a:buClrTx/>
+                <a:buSzTx/>
+                <a:buFontTx/>
+                <a:buNone/>
+                <a:tabLst/>
+                <a:defRPr/>
+              </a:pPr>
+              <a:t>27</a:t>
+            </a:fld>
+            <a:endParaRPr kumimoji="0" lang="en-US" sz="1200" b="0" i="0" u="none" strike="noStrike" kern="1200" cap="none" spc="0" normalizeH="0" baseline="0" noProof="0" dirty="0">
+              <a:ln>
+                <a:noFill/>
+              </a:ln>
+              <a:solidFill>
+                <a:prstClr val="black"/>
+              </a:solidFill>
+              <a:effectLst/>
+              <a:uLnTx/>
+              <a:uFillTx/>
+              <a:latin typeface="Calibri" panose="020F0502020204030204"/>
+              <a:ea typeface="+mn-ea"/>
+              <a:cs typeface="+mn-cs"/>
+            </a:endParaRPr>
+          </a:p>
+        </p:txBody>
+      </p:sp>
+    </p:spTree>
+    <p:extLst>
+      <p:ext uri="{BB962C8B-B14F-4D97-AF65-F5344CB8AC3E}">
+        <p14:creationId xmlns:p14="http://schemas.microsoft.com/office/powerpoint/2010/main" val="1917725678"/>
+      </p:ext>
+    </p:extLst>
+  </p:cSld>
+  <p:clrMapOvr>
+    <a:masterClrMapping/>
+  </p:clrMapOvr>
+</p:notes>
+</file>
+
 <file path=ppt/notesSlides/notesSlide3.xml><?xml version="1.0" encoding="utf-8"?>
 <p:notes xmlns:a="http://schemas.openxmlformats.org/drawingml/2006/main" xmlns:r="http://schemas.openxmlformats.org/officeDocument/2006/relationships" xmlns:p="http://schemas.openxmlformats.org/presentationml/2006/main">
   <p:cSld>
@@ -4527,6 +4729,183 @@
         <p:cNvPr id="1" name="">
           <a:extLst>
             <a:ext uri="{FF2B5EF4-FFF2-40B4-BE49-F238E27FC236}">
+              <a16:creationId xmlns:a16="http://schemas.microsoft.com/office/drawing/2014/main" id="{A9203B94-A0D1-8BA2-52CA-BA275829F031}"/>
+            </a:ext>
+          </a:extLst>
+        </p:cNvPr>
+        <p:cNvGrpSpPr/>
+        <p:nvPr/>
+      </p:nvGrpSpPr>
+      <p:grpSpPr>
+        <a:xfrm>
+          <a:off x="0" y="0"/>
+          <a:ext cx="0" cy="0"/>
+          <a:chOff x="0" y="0"/>
+          <a:chExt cx="0" cy="0"/>
+        </a:xfrm>
+      </p:grpSpPr>
+      <p:sp>
+        <p:nvSpPr>
+          <p:cNvPr id="2" name="Slide Image Placeholder 1">
+            <a:extLst>
+              <a:ext uri="{FF2B5EF4-FFF2-40B4-BE49-F238E27FC236}">
+                <a16:creationId xmlns:a16="http://schemas.microsoft.com/office/drawing/2014/main" id="{5874A54C-C3B9-1419-2C5D-F1862ED9DE2C}"/>
+              </a:ext>
+            </a:extLst>
+          </p:cNvPr>
+          <p:cNvSpPr>
+            <a:spLocks noGrp="1" noRot="1" noChangeAspect="1"/>
+          </p:cNvSpPr>
+          <p:nvPr>
+            <p:ph type="sldImg"/>
+          </p:nvPr>
+        </p:nvSpPr>
+        <p:spPr/>
+      </p:sp>
+      <p:sp>
+        <p:nvSpPr>
+          <p:cNvPr id="3" name="Notes Placeholder 2">
+            <a:extLst>
+              <a:ext uri="{FF2B5EF4-FFF2-40B4-BE49-F238E27FC236}">
+                <a16:creationId xmlns:a16="http://schemas.microsoft.com/office/drawing/2014/main" id="{2AACAF55-006E-189E-33FF-B208890EB903}"/>
+              </a:ext>
+            </a:extLst>
+          </p:cNvPr>
+          <p:cNvSpPr>
+            <a:spLocks noGrp="1"/>
+          </p:cNvSpPr>
+          <p:nvPr>
+            <p:ph type="body" idx="1"/>
+          </p:nvPr>
+        </p:nvSpPr>
+        <p:spPr/>
+        <p:txBody>
+          <a:bodyPr/>
+          <a:lstStyle/>
+          <a:p>
+            <a:r>
+              <a:rPr lang="en-US" dirty="0"/>
+              <a:t>For each challenge, list out the key high-level goals.</a:t>
+            </a:r>
+          </a:p>
+          <a:p>
+            <a:r>
+              <a:rPr lang="en-US" dirty="0"/>
+              <a:t>If there are important specifications, list them here, or remind students to “read the student guide!” </a:t>
+            </a:r>
+          </a:p>
+        </p:txBody>
+      </p:sp>
+      <p:sp>
+        <p:nvSpPr>
+          <p:cNvPr id="4" name="Slide Number Placeholder 3">
+            <a:extLst>
+              <a:ext uri="{FF2B5EF4-FFF2-40B4-BE49-F238E27FC236}">
+                <a16:creationId xmlns:a16="http://schemas.microsoft.com/office/drawing/2014/main" id="{29AB6E74-35AF-E136-F99A-BB2162FFF253}"/>
+              </a:ext>
+            </a:extLst>
+          </p:cNvPr>
+          <p:cNvSpPr>
+            <a:spLocks noGrp="1"/>
+          </p:cNvSpPr>
+          <p:nvPr>
+            <p:ph type="sldNum" sz="quarter" idx="10"/>
+          </p:nvPr>
+        </p:nvSpPr>
+        <p:spPr/>
+        <p:txBody>
+          <a:bodyPr/>
+          <a:lstStyle/>
+          <a:p>
+            <a:pPr marL="0" marR="0" lvl="0" indent="0" algn="r" defTabSz="914400" rtl="0" eaLnBrk="1" fontAlgn="auto" latinLnBrk="0" hangingPunct="1">
+              <a:lnSpc>
+                <a:spcPct val="100000"/>
+              </a:lnSpc>
+              <a:spcBef>
+                <a:spcPts val="0"/>
+              </a:spcBef>
+              <a:spcAft>
+                <a:spcPts val="0"/>
+              </a:spcAft>
+              <a:buClrTx/>
+              <a:buSzTx/>
+              <a:buFontTx/>
+              <a:buNone/>
+              <a:tabLst/>
+              <a:defRPr/>
+            </a:pPr>
+            <a:fld id="{871D71AE-08D6-4951-B1CF-CF97299DB5EB}" type="slidenum">
+              <a:rPr kumimoji="0" lang="en-US" sz="1200" b="0" i="0" u="none" strike="noStrike" kern="1200" cap="none" spc="0" normalizeH="0" baseline="0" noProof="0" smtClean="0">
+                <a:ln>
+                  <a:noFill/>
+                </a:ln>
+                <a:solidFill>
+                  <a:prstClr val="black"/>
+                </a:solidFill>
+                <a:effectLst/>
+                <a:uLnTx/>
+                <a:uFillTx/>
+                <a:latin typeface="Calibri" panose="020F0502020204030204"/>
+                <a:ea typeface="+mn-ea"/>
+                <a:cs typeface="+mn-cs"/>
+              </a:rPr>
+              <a:pPr marL="0" marR="0" lvl="0" indent="0" algn="r" defTabSz="914400" rtl="0" eaLnBrk="1" fontAlgn="auto" latinLnBrk="0" hangingPunct="1">
+                <a:lnSpc>
+                  <a:spcPct val="100000"/>
+                </a:lnSpc>
+                <a:spcBef>
+                  <a:spcPts val="0"/>
+                </a:spcBef>
+                <a:spcAft>
+                  <a:spcPts val="0"/>
+                </a:spcAft>
+                <a:buClrTx/>
+                <a:buSzTx/>
+                <a:buFontTx/>
+                <a:buNone/>
+                <a:tabLst/>
+                <a:defRPr/>
+              </a:pPr>
+              <a:t>8</a:t>
+            </a:fld>
+            <a:endParaRPr kumimoji="0" lang="en-US" sz="1200" b="0" i="0" u="none" strike="noStrike" kern="1200" cap="none" spc="0" normalizeH="0" baseline="0" noProof="0">
+              <a:ln>
+                <a:noFill/>
+              </a:ln>
+              <a:solidFill>
+                <a:prstClr val="black"/>
+              </a:solidFill>
+              <a:effectLst/>
+              <a:uLnTx/>
+              <a:uFillTx/>
+              <a:latin typeface="Calibri" panose="020F0502020204030204"/>
+              <a:ea typeface="+mn-ea"/>
+              <a:cs typeface="+mn-cs"/>
+            </a:endParaRPr>
+          </a:p>
+        </p:txBody>
+      </p:sp>
+    </p:spTree>
+    <p:extLst>
+      <p:ext uri="{BB962C8B-B14F-4D97-AF65-F5344CB8AC3E}">
+        <p14:creationId xmlns:p14="http://schemas.microsoft.com/office/powerpoint/2010/main" val="769841124"/>
+      </p:ext>
+    </p:extLst>
+  </p:cSld>
+  <p:clrMapOvr>
+    <a:masterClrMapping/>
+  </p:clrMapOvr>
+</p:notes>
+</file>
+
+<file path=ppt/notesSlides/notesSlide8.xml><?xml version="1.0" encoding="utf-8"?>
+<p:notes xmlns:a="http://schemas.openxmlformats.org/drawingml/2006/main" xmlns:r="http://schemas.openxmlformats.org/officeDocument/2006/relationships" xmlns:p="http://schemas.openxmlformats.org/presentationml/2006/main">
+  <p:cSld>
+    <p:spTree>
+      <p:nvGrpSpPr>
+        <p:cNvPr id="1" name="">
+          <a:extLst>
+            <a:ext uri="{FF2B5EF4-FFF2-40B4-BE49-F238E27FC236}">
               <a16:creationId xmlns:a16="http://schemas.microsoft.com/office/drawing/2014/main" id="{5865634C-F96E-C8F4-B1BF-DFD904DACBA5}"/>
             </a:ext>
           </a:extLst>
@@ -4688,7 +5067,7 @@
                 <a:tabLst/>
                 <a:defRPr/>
               </a:pPr>
-              <a:t>9</a:t>
+              <a:t>10</a:t>
             </a:fld>
             <a:endParaRPr kumimoji="0" lang="en-US" sz="1200" b="0" i="0" u="none" strike="noStrike" kern="1200" cap="none" spc="0" normalizeH="0" baseline="0" noProof="0">
               <a:ln>
@@ -4720,7 +5099,7 @@
 </p:notes>
 </file>
 
-<file path=ppt/notesSlides/notesSlide8.xml><?xml version="1.0" encoding="utf-8"?>
+<file path=ppt/notesSlides/notesSlide9.xml><?xml version="1.0" encoding="utf-8"?>
 <p:notes xmlns:a="http://schemas.openxmlformats.org/drawingml/2006/main" xmlns:r="http://schemas.openxmlformats.org/officeDocument/2006/relationships" xmlns:p="http://schemas.openxmlformats.org/presentationml/2006/main">
   <p:cSld>
     <p:spTree>
@@ -4865,7 +5244,7 @@
                 <a:tabLst/>
                 <a:defRPr/>
               </a:pPr>
-              <a:t>10</a:t>
+              <a:t>11</a:t>
             </a:fld>
             <a:endParaRPr kumimoji="0" lang="en-US" sz="1200" b="0" i="0" u="none" strike="noStrike" kern="1200" cap="none" spc="0" normalizeH="0" baseline="0" noProof="0">
               <a:ln>
@@ -4888,207 +5267,6 @@
     <p:extLst>
       <p:ext uri="{BB962C8B-B14F-4D97-AF65-F5344CB8AC3E}">
         <p14:creationId xmlns:p14="http://schemas.microsoft.com/office/powerpoint/2010/main" val="1451531216"/>
-      </p:ext>
-    </p:extLst>
-  </p:cSld>
-  <p:clrMapOvr>
-    <a:masterClrMapping/>
-  </p:clrMapOvr>
-</p:notes>
-</file>
-
-<file path=ppt/notesSlides/notesSlide9.xml><?xml version="1.0" encoding="utf-8"?>
-<p:notes xmlns:a="http://schemas.openxmlformats.org/drawingml/2006/main" xmlns:r="http://schemas.openxmlformats.org/officeDocument/2006/relationships" xmlns:p="http://schemas.openxmlformats.org/presentationml/2006/main">
-  <p:cSld>
-    <p:spTree>
-      <p:nvGrpSpPr>
-        <p:cNvPr id="1" name="">
-          <a:extLst>
-            <a:ext uri="{FF2B5EF4-FFF2-40B4-BE49-F238E27FC236}">
-              <a16:creationId xmlns:a16="http://schemas.microsoft.com/office/drawing/2014/main" id="{E9544A43-CA26-FD5B-60E9-4A4E2234D37D}"/>
-            </a:ext>
-          </a:extLst>
-        </p:cNvPr>
-        <p:cNvGrpSpPr/>
-        <p:nvPr/>
-      </p:nvGrpSpPr>
-      <p:grpSpPr>
-        <a:xfrm>
-          <a:off x="0" y="0"/>
-          <a:ext cx="0" cy="0"/>
-          <a:chOff x="0" y="0"/>
-          <a:chExt cx="0" cy="0"/>
-        </a:xfrm>
-      </p:grpSpPr>
-      <p:sp>
-        <p:nvSpPr>
-          <p:cNvPr id="2" name="Slide Image Placeholder 1">
-            <a:extLst>
-              <a:ext uri="{FF2B5EF4-FFF2-40B4-BE49-F238E27FC236}">
-                <a16:creationId xmlns:a16="http://schemas.microsoft.com/office/drawing/2014/main" id="{7C4BB357-40A9-F43B-F393-E5E226AE7CB9}"/>
-              </a:ext>
-            </a:extLst>
-          </p:cNvPr>
-          <p:cNvSpPr>
-            <a:spLocks noGrp="1" noRot="1" noChangeAspect="1"/>
-          </p:cNvSpPr>
-          <p:nvPr>
-            <p:ph type="sldImg"/>
-          </p:nvPr>
-        </p:nvSpPr>
-        <p:spPr/>
-      </p:sp>
-      <p:sp>
-        <p:nvSpPr>
-          <p:cNvPr id="3" name="Notes Placeholder 2">
-            <a:extLst>
-              <a:ext uri="{FF2B5EF4-FFF2-40B4-BE49-F238E27FC236}">
-                <a16:creationId xmlns:a16="http://schemas.microsoft.com/office/drawing/2014/main" id="{5BB54B11-589E-C1A1-3D4C-9C3CAC2D038C}"/>
-              </a:ext>
-            </a:extLst>
-          </p:cNvPr>
-          <p:cNvSpPr>
-            <a:spLocks noGrp="1"/>
-          </p:cNvSpPr>
-          <p:nvPr>
-            <p:ph type="body" idx="1"/>
-          </p:nvPr>
-        </p:nvSpPr>
-        <p:spPr/>
-        <p:txBody>
-          <a:bodyPr/>
-          <a:lstStyle/>
-          <a:p>
-            <a:r>
-              <a:rPr lang="en-US" dirty="0"/>
-              <a:t>Template for a lecture slide with bullets (if you need them).</a:t>
-            </a:r>
-          </a:p>
-          <a:p>
-            <a:endParaRPr lang="en-US" dirty="0"/>
-          </a:p>
-          <a:p>
-            <a:r>
-              <a:rPr lang="en-US" dirty="0"/>
-              <a:t>Try to NOT use bullet lists in your presentation.  </a:t>
-            </a:r>
-          </a:p>
-          <a:p>
-            <a:r>
-              <a:rPr lang="en-US" dirty="0"/>
-              <a:t>Diagrams, puppy pictures, </a:t>
-            </a:r>
-            <a:r>
-              <a:rPr lang="en-US" dirty="0" err="1"/>
-              <a:t>etc</a:t>
-            </a:r>
-            <a:r>
-              <a:rPr lang="en-US" dirty="0"/>
-              <a:t> are always better. </a:t>
-            </a:r>
-            <a:r>
-              <a:rPr lang="en-US" dirty="0">
-                <a:sym typeface="Wingdings" panose="05000000000000000000" pitchFamily="2" charset="2"/>
-              </a:rPr>
-              <a:t></a:t>
-            </a:r>
-            <a:endParaRPr lang="en-US" dirty="0"/>
-          </a:p>
-        </p:txBody>
-      </p:sp>
-      <p:sp>
-        <p:nvSpPr>
-          <p:cNvPr id="4" name="Slide Number Placeholder 3">
-            <a:extLst>
-              <a:ext uri="{FF2B5EF4-FFF2-40B4-BE49-F238E27FC236}">
-                <a16:creationId xmlns:a16="http://schemas.microsoft.com/office/drawing/2014/main" id="{EAA2C23F-350C-1009-F9BB-3FA904F734A6}"/>
-              </a:ext>
-            </a:extLst>
-          </p:cNvPr>
-          <p:cNvSpPr>
-            <a:spLocks noGrp="1"/>
-          </p:cNvSpPr>
-          <p:nvPr>
-            <p:ph type="sldNum" sz="quarter" idx="5"/>
-          </p:nvPr>
-        </p:nvSpPr>
-        <p:spPr/>
-        <p:txBody>
-          <a:bodyPr/>
-          <a:lstStyle/>
-          <a:p>
-            <a:pPr marL="0" marR="0" lvl="0" indent="0" algn="r" defTabSz="914400" rtl="0" eaLnBrk="1" fontAlgn="auto" latinLnBrk="0" hangingPunct="1">
-              <a:lnSpc>
-                <a:spcPct val="100000"/>
-              </a:lnSpc>
-              <a:spcBef>
-                <a:spcPts val="0"/>
-              </a:spcBef>
-              <a:spcAft>
-                <a:spcPts val="0"/>
-              </a:spcAft>
-              <a:buClrTx/>
-              <a:buSzTx/>
-              <a:buFontTx/>
-              <a:buNone/>
-              <a:tabLst/>
-              <a:defRPr/>
-            </a:pPr>
-            <a:fld id="{72A19410-49C3-46C5-A633-999FD8C4418C}" type="slidenum">
-              <a:rPr kumimoji="0" lang="en-US" sz="1200" b="0" i="0" u="none" strike="noStrike" kern="1200" cap="none" spc="0" normalizeH="0" baseline="0" noProof="0" smtClean="0">
-                <a:ln>
-                  <a:noFill/>
-                </a:ln>
-                <a:solidFill>
-                  <a:prstClr val="black"/>
-                </a:solidFill>
-                <a:effectLst/>
-                <a:uLnTx/>
-                <a:uFillTx/>
-                <a:latin typeface="Calibri" panose="020F0502020204030204"/>
-                <a:ea typeface="+mn-ea"/>
-                <a:cs typeface="+mn-cs"/>
-              </a:rPr>
-              <a:pPr marL="0" marR="0" lvl="0" indent="0" algn="r" defTabSz="914400" rtl="0" eaLnBrk="1" fontAlgn="auto" latinLnBrk="0" hangingPunct="1">
-                <a:lnSpc>
-                  <a:spcPct val="100000"/>
-                </a:lnSpc>
-                <a:spcBef>
-                  <a:spcPts val="0"/>
-                </a:spcBef>
-                <a:spcAft>
-                  <a:spcPts val="0"/>
-                </a:spcAft>
-                <a:buClrTx/>
-                <a:buSzTx/>
-                <a:buFontTx/>
-                <a:buNone/>
-                <a:tabLst/>
-                <a:defRPr/>
-              </a:pPr>
-              <a:t>12</a:t>
-            </a:fld>
-            <a:endParaRPr kumimoji="0" lang="en-US" sz="1200" b="0" i="0" u="none" strike="noStrike" kern="1200" cap="none" spc="0" normalizeH="0" baseline="0" noProof="0">
-              <a:ln>
-                <a:noFill/>
-              </a:ln>
-              <a:solidFill>
-                <a:prstClr val="black"/>
-              </a:solidFill>
-              <a:effectLst/>
-              <a:uLnTx/>
-              <a:uFillTx/>
-              <a:latin typeface="Calibri" panose="020F0502020204030204"/>
-              <a:ea typeface="+mn-ea"/>
-              <a:cs typeface="+mn-cs"/>
-            </a:endParaRPr>
-          </a:p>
-        </p:txBody>
-      </p:sp>
-    </p:spTree>
-    <p:extLst>
-      <p:ext uri="{BB962C8B-B14F-4D97-AF65-F5344CB8AC3E}">
-        <p14:creationId xmlns:p14="http://schemas.microsoft.com/office/powerpoint/2010/main" val="42463"/>
       </p:ext>
     </p:extLst>
   </p:cSld>
@@ -5268,7 +5446,7 @@
           <a:p>
             <a:fld id="{DFED49D2-CC62-47A6-8FD4-1840AC422660}" type="datetimeFigureOut">
               <a:rPr lang="en-US" smtClean="0"/>
-              <a:t>2/4/26</a:t>
+              <a:t>3/24/26</a:t>
             </a:fld>
             <a:endParaRPr lang="en-US"/>
           </a:p>
@@ -5623,7 +5801,7 @@
           <a:p>
             <a:fld id="{DFED49D2-CC62-47A6-8FD4-1840AC422660}" type="datetimeFigureOut">
               <a:rPr lang="en-US" smtClean="0"/>
-              <a:t>2/4/26</a:t>
+              <a:t>3/24/26</a:t>
             </a:fld>
             <a:endParaRPr lang="en-US"/>
           </a:p>
@@ -5821,7 +5999,7 @@
           <a:p>
             <a:fld id="{DFED49D2-CC62-47A6-8FD4-1840AC422660}" type="datetimeFigureOut">
               <a:rPr lang="en-US" smtClean="0"/>
-              <a:t>2/4/26</a:t>
+              <a:t>3/24/26</a:t>
             </a:fld>
             <a:endParaRPr lang="en-US"/>
           </a:p>
@@ -6029,7 +6207,7 @@
           <a:p>
             <a:fld id="{DFED49D2-CC62-47A6-8FD4-1840AC422660}" type="datetimeFigureOut">
               <a:rPr lang="en-US" smtClean="0"/>
-              <a:t>2/4/26</a:t>
+              <a:t>3/24/26</a:t>
             </a:fld>
             <a:endParaRPr lang="en-US"/>
           </a:p>
@@ -6596,7 +6774,7 @@
           <a:p>
             <a:fld id="{DFED49D2-CC62-47A6-8FD4-1840AC422660}" type="datetimeFigureOut">
               <a:rPr lang="en-US" smtClean="0"/>
-              <a:t>2/4/26</a:t>
+              <a:t>3/24/26</a:t>
             </a:fld>
             <a:endParaRPr lang="en-US" dirty="0"/>
           </a:p>
@@ -6852,7 +7030,7 @@
           <a:p>
             <a:fld id="{DFED49D2-CC62-47A6-8FD4-1840AC422660}" type="datetimeFigureOut">
               <a:rPr lang="en-US" smtClean="0"/>
-              <a:t>2/4/26</a:t>
+              <a:t>3/24/26</a:t>
             </a:fld>
             <a:endParaRPr lang="en-US"/>
           </a:p>
@@ -7225,7 +7403,7 @@
           <a:p>
             <a:fld id="{DFED49D2-CC62-47A6-8FD4-1840AC422660}" type="datetimeFigureOut">
               <a:rPr lang="en-US" smtClean="0"/>
-              <a:t>2/4/26</a:t>
+              <a:t>3/24/26</a:t>
             </a:fld>
             <a:endParaRPr lang="en-US"/>
           </a:p>
@@ -7562,7 +7740,7 @@
           <a:p>
             <a:fld id="{DFED49D2-CC62-47A6-8FD4-1840AC422660}" type="datetimeFigureOut">
               <a:rPr lang="en-US" smtClean="0"/>
-              <a:t>2/4/26</a:t>
+              <a:t>3/24/26</a:t>
             </a:fld>
             <a:endParaRPr lang="en-US"/>
           </a:p>
@@ -7974,7 +8152,7 @@
           <a:p>
             <a:fld id="{DFED49D2-CC62-47A6-8FD4-1840AC422660}" type="datetimeFigureOut">
               <a:rPr lang="en-US" smtClean="0"/>
-              <a:t>2/4/26</a:t>
+              <a:t>3/24/26</a:t>
             </a:fld>
             <a:endParaRPr lang="en-US"/>
           </a:p>
@@ -8120,7 +8298,7 @@
           <a:p>
             <a:fld id="{DFED49D2-CC62-47A6-8FD4-1840AC422660}" type="datetimeFigureOut">
               <a:rPr lang="en-US" smtClean="0"/>
-              <a:t>2/4/26</a:t>
+              <a:t>3/24/26</a:t>
             </a:fld>
             <a:endParaRPr lang="en-US"/>
           </a:p>
@@ -8233,7 +8411,7 @@
           <a:p>
             <a:fld id="{DFED49D2-CC62-47A6-8FD4-1840AC422660}" type="datetimeFigureOut">
               <a:rPr lang="en-US" smtClean="0"/>
-              <a:t>2/4/26</a:t>
+              <a:t>3/24/26</a:t>
             </a:fld>
             <a:endParaRPr lang="en-US"/>
           </a:p>
@@ -8544,7 +8722,7 @@
           <a:p>
             <a:fld id="{DFED49D2-CC62-47A6-8FD4-1840AC422660}" type="datetimeFigureOut">
               <a:rPr lang="en-US" smtClean="0"/>
-              <a:t>2/4/26</a:t>
+              <a:t>3/24/26</a:t>
             </a:fld>
             <a:endParaRPr lang="en-US"/>
           </a:p>
@@ -8785,7 +8963,7 @@
           <a:p>
             <a:fld id="{DFED49D2-CC62-47A6-8FD4-1840AC422660}" type="datetimeFigureOut">
               <a:rPr lang="en-US" smtClean="0"/>
-              <a:t>2/4/26</a:t>
+              <a:t>3/24/26</a:t>
             </a:fld>
             <a:endParaRPr lang="en-US"/>
           </a:p>
@@ -9268,10 +9446,10 @@
           <p:nvPr/>
         </p:nvPicPr>
         <p:blipFill>
-          <a:blip r:embed="rId3">
+          <a:blip>
             <a:extLst>
               <a:ext uri="{96DAC541-7B7A-43D3-8B79-37D633B846F1}">
-                <asvg:svgBlip xmlns:asvg="http://schemas.microsoft.com/office/drawing/2016/SVG/main" r:embed="rId4"/>
+                <asvg:svgBlip xmlns:asvg="http://schemas.microsoft.com/office/drawing/2016/SVG/main" r:embed="rId3"/>
               </a:ext>
             </a:extLst>
           </a:blip>
@@ -9380,6 +9558,199 @@
 </file>
 
 <file path=ppt/slides/slide10.xml><?xml version="1.0" encoding="utf-8"?>
+<p:sld xmlns:a="http://schemas.openxmlformats.org/drawingml/2006/main" xmlns:r="http://schemas.openxmlformats.org/officeDocument/2006/relationships" xmlns:p="http://schemas.openxmlformats.org/presentationml/2006/main">
+  <p:cSld>
+    <p:spTree>
+      <p:nvGrpSpPr>
+        <p:cNvPr id="1" name="">
+          <a:extLst>
+            <a:ext uri="{FF2B5EF4-FFF2-40B4-BE49-F238E27FC236}">
+              <a16:creationId xmlns:a16="http://schemas.microsoft.com/office/drawing/2014/main" id="{23C0D43E-7A5A-3A63-4683-DA58769BA974}"/>
+            </a:ext>
+          </a:extLst>
+        </p:cNvPr>
+        <p:cNvGrpSpPr/>
+        <p:nvPr/>
+      </p:nvGrpSpPr>
+      <p:grpSpPr>
+        <a:xfrm>
+          <a:off x="0" y="0"/>
+          <a:ext cx="0" cy="0"/>
+          <a:chOff x="0" y="0"/>
+          <a:chExt cx="0" cy="0"/>
+        </a:xfrm>
+      </p:grpSpPr>
+      <p:sp>
+        <p:nvSpPr>
+          <p:cNvPr id="3" name="Content Placeholder 2">
+            <a:extLst>
+              <a:ext uri="{FF2B5EF4-FFF2-40B4-BE49-F238E27FC236}">
+                <a16:creationId xmlns:a16="http://schemas.microsoft.com/office/drawing/2014/main" id="{3A79DB28-B093-94A7-B8B1-60EF8DF01951}"/>
+              </a:ext>
+            </a:extLst>
+          </p:cNvPr>
+          <p:cNvSpPr>
+            <a:spLocks noGrp="1"/>
+          </p:cNvSpPr>
+          <p:nvPr>
+            <p:ph idx="1"/>
+          </p:nvPr>
+        </p:nvSpPr>
+        <p:spPr/>
+        <p:txBody>
+          <a:bodyPr>
+            <a:normAutofit/>
+          </a:bodyPr>
+          <a:lstStyle/>
+          <a:p>
+            <a:pPr marL="0" indent="0">
+              <a:buNone/>
+            </a:pPr>
+            <a:r>
+              <a:rPr lang="en-US" dirty="0">
+                <a:latin typeface="Segoe UI" panose="020B0502040204020203" pitchFamily="34" charset="0"/>
+                <a:cs typeface="Segoe UI" panose="020B0502040204020203" pitchFamily="34" charset="0"/>
+              </a:rPr>
+              <a:t>It's time to build the first version of </a:t>
+            </a:r>
+            <a:r>
+              <a:rPr lang="en-US" dirty="0" err="1">
+                <a:latin typeface="Segoe UI" panose="020B0502040204020203" pitchFamily="34" charset="0"/>
+                <a:cs typeface="Segoe UI" panose="020B0502040204020203" pitchFamily="34" charset="0"/>
+              </a:rPr>
+              <a:t>WanderAI's</a:t>
+            </a:r>
+            <a:r>
+              <a:rPr lang="en-US" dirty="0">
+                <a:latin typeface="Segoe UI" panose="020B0502040204020203" pitchFamily="34" charset="0"/>
+                <a:cs typeface="Segoe UI" panose="020B0502040204020203" pitchFamily="34" charset="0"/>
+              </a:rPr>
+              <a:t> Travel Planner service! In this challenge, you will create a Flask web application that leverages the Microsoft Agent Framework to generate personalized travel itineraries.</a:t>
+            </a:r>
+          </a:p>
+          <a:p>
+            <a:pPr marL="0" indent="0">
+              <a:buNone/>
+            </a:pPr>
+            <a:endParaRPr lang="en-US" dirty="0">
+              <a:latin typeface="Segoe UI" panose="020B0502040204020203" pitchFamily="34" charset="0"/>
+              <a:cs typeface="Segoe UI" panose="020B0502040204020203" pitchFamily="34" charset="0"/>
+            </a:endParaRPr>
+          </a:p>
+          <a:p>
+            <a:pPr marL="0" indent="0">
+              <a:buNone/>
+            </a:pPr>
+            <a:r>
+              <a:rPr lang="en-US" dirty="0">
+                <a:latin typeface="Segoe UI" panose="020B0502040204020203" pitchFamily="34" charset="0"/>
+                <a:cs typeface="Segoe UI" panose="020B0502040204020203" pitchFamily="34" charset="0"/>
+              </a:rPr>
+              <a:t>Your application will accept user travel preferences through a web form and use an AI agent to create beautiful, customized trip plans. The agent will have access to tools that provide real-time information like weather data and current date/time.</a:t>
+            </a:r>
+          </a:p>
+        </p:txBody>
+      </p:sp>
+      <p:sp>
+        <p:nvSpPr>
+          <p:cNvPr id="4" name="Text Placeholder 3">
+            <a:extLst>
+              <a:ext uri="{FF2B5EF4-FFF2-40B4-BE49-F238E27FC236}">
+                <a16:creationId xmlns:a16="http://schemas.microsoft.com/office/drawing/2014/main" id="{4397DB4C-AE02-1957-0E69-B8C672199F8F}"/>
+              </a:ext>
+            </a:extLst>
+          </p:cNvPr>
+          <p:cNvSpPr>
+            <a:spLocks noGrp="1"/>
+          </p:cNvSpPr>
+          <p:nvPr>
+            <p:ph type="body" sz="quarter" idx="13"/>
+          </p:nvPr>
+        </p:nvSpPr>
+        <p:spPr/>
+        <p:txBody>
+          <a:bodyPr>
+            <a:normAutofit/>
+          </a:bodyPr>
+          <a:lstStyle/>
+          <a:p>
+            <a:r>
+              <a:rPr lang="en-US" sz="3200" b="1" dirty="0">
+                <a:solidFill>
+                  <a:srgbClr val="7030A0"/>
+                </a:solidFill>
+                <a:latin typeface="Segoe UI" panose="020B0502040204020203" pitchFamily="34" charset="0"/>
+                <a:cs typeface="Segoe UI" panose="020B0502040204020203" pitchFamily="34" charset="0"/>
+              </a:rPr>
+              <a:t>Build Your MVP - Ship the first version of </a:t>
+            </a:r>
+            <a:r>
+              <a:rPr lang="en-US" sz="3200" b="1" dirty="0" err="1">
+                <a:solidFill>
+                  <a:srgbClr val="7030A0"/>
+                </a:solidFill>
+                <a:latin typeface="Segoe UI" panose="020B0502040204020203" pitchFamily="34" charset="0"/>
+                <a:cs typeface="Segoe UI" panose="020B0502040204020203" pitchFamily="34" charset="0"/>
+              </a:rPr>
+              <a:t>WanderAI</a:t>
+            </a:r>
+            <a:r>
+              <a:rPr lang="en-US" sz="3200" b="1" dirty="0">
+                <a:solidFill>
+                  <a:srgbClr val="7030A0"/>
+                </a:solidFill>
+                <a:latin typeface="Segoe UI" panose="020B0502040204020203" pitchFamily="34" charset="0"/>
+                <a:cs typeface="Segoe UI" panose="020B0502040204020203" pitchFamily="34" charset="0"/>
+              </a:rPr>
+              <a:t>!</a:t>
+            </a:r>
+            <a:endParaRPr lang="en-US" dirty="0"/>
+          </a:p>
+        </p:txBody>
+      </p:sp>
+      <p:sp>
+        <p:nvSpPr>
+          <p:cNvPr id="6" name="Title 5">
+            <a:extLst>
+              <a:ext uri="{FF2B5EF4-FFF2-40B4-BE49-F238E27FC236}">
+                <a16:creationId xmlns:a16="http://schemas.microsoft.com/office/drawing/2014/main" id="{B6E493CF-4088-D4E5-DF71-E2186C7A7D2C}"/>
+              </a:ext>
+            </a:extLst>
+          </p:cNvPr>
+          <p:cNvSpPr>
+            <a:spLocks noGrp="1"/>
+          </p:cNvSpPr>
+          <p:nvPr>
+            <p:ph type="title"/>
+          </p:nvPr>
+        </p:nvSpPr>
+        <p:spPr/>
+        <p:txBody>
+          <a:bodyPr/>
+          <a:lstStyle/>
+          <a:p>
+            <a:r>
+              <a:rPr lang="en-GB" dirty="0"/>
+              <a:t>Challenge #2</a:t>
+            </a:r>
+            <a:endParaRPr lang="en-DE" dirty="0"/>
+          </a:p>
+        </p:txBody>
+      </p:sp>
+    </p:spTree>
+    <p:extLst>
+      <p:ext uri="{BB962C8B-B14F-4D97-AF65-F5344CB8AC3E}">
+        <p14:creationId xmlns:p14="http://schemas.microsoft.com/office/powerpoint/2010/main" val="2192518200"/>
+      </p:ext>
+    </p:extLst>
+  </p:cSld>
+  <p:clrMapOvr>
+    <a:masterClrMapping/>
+  </p:clrMapOvr>
+</p:sld>
+</file>
+
+<file path=ppt/slides/slide11.xml><?xml version="1.0" encoding="utf-8"?>
 <p:sld xmlns:a="http://schemas.openxmlformats.org/drawingml/2006/main" xmlns:r="http://schemas.openxmlformats.org/officeDocument/2006/relationships" xmlns:p="http://schemas.openxmlformats.org/presentationml/2006/main">
   <p:cSld>
     <p:spTree>
@@ -9707,7 +10078,7 @@
 </p:sld>
 </file>
 
-<file path=ppt/slides/slide11.xml><?xml version="1.0" encoding="utf-8"?>
+<file path=ppt/slides/slide12.xml><?xml version="1.0" encoding="utf-8"?>
 <p:sld xmlns:a="http://schemas.openxmlformats.org/drawingml/2006/main" xmlns:r="http://schemas.openxmlformats.org/officeDocument/2006/relationships" xmlns:p="http://schemas.openxmlformats.org/presentationml/2006/main">
   <p:cSld>
     <p:spTree>
@@ -9811,7 +10182,7 @@
 </p:sld>
 </file>
 
-<file path=ppt/slides/slide12.xml><?xml version="1.0" encoding="utf-8"?>
+<file path=ppt/slides/slide13.xml><?xml version="1.0" encoding="utf-8"?>
 <p:sld xmlns:a="http://schemas.openxmlformats.org/drawingml/2006/main" xmlns:r="http://schemas.openxmlformats.org/officeDocument/2006/relationships" xmlns:p="http://schemas.openxmlformats.org/presentationml/2006/main">
   <p:cSld>
     <p:spTree>
@@ -10099,7 +10470,7 @@
 </p:sld>
 </file>
 
-<file path=ppt/slides/slide13.xml><?xml version="1.0" encoding="utf-8"?>
+<file path=ppt/slides/slide14.xml><?xml version="1.0" encoding="utf-8"?>
 <p:sld xmlns:a="http://schemas.openxmlformats.org/drawingml/2006/main" xmlns:r="http://schemas.openxmlformats.org/officeDocument/2006/relationships" xmlns:p="http://schemas.openxmlformats.org/presentationml/2006/main">
   <p:cSld>
     <p:spTree>
@@ -10425,7 +10796,7 @@
 </p:sld>
 </file>
 
-<file path=ppt/slides/slide14.xml><?xml version="1.0" encoding="utf-8"?>
+<file path=ppt/slides/slide15.xml><?xml version="1.0" encoding="utf-8"?>
 <p:sld xmlns:a="http://schemas.openxmlformats.org/drawingml/2006/main" xmlns:r="http://schemas.openxmlformats.org/officeDocument/2006/relationships" xmlns:p="http://schemas.openxmlformats.org/presentationml/2006/main">
   <p:cSld>
     <p:spTree>
@@ -10529,7 +10900,7 @@
 </p:sld>
 </file>
 
-<file path=ppt/slides/slide15.xml><?xml version="1.0" encoding="utf-8"?>
+<file path=ppt/slides/slide16.xml><?xml version="1.0" encoding="utf-8"?>
 <p:sld xmlns:a="http://schemas.openxmlformats.org/drawingml/2006/main" xmlns:r="http://schemas.openxmlformats.org/officeDocument/2006/relationships" xmlns:p="http://schemas.openxmlformats.org/presentationml/2006/main">
   <p:cSld>
     <p:spTree>
@@ -10795,7 +11166,7 @@
 </p:sld>
 </file>
 
-<file path=ppt/slides/slide16.xml><?xml version="1.0" encoding="utf-8"?>
+<file path=ppt/slides/slide17.xml><?xml version="1.0" encoding="utf-8"?>
 <p:sld xmlns:a="http://schemas.openxmlformats.org/drawingml/2006/main" xmlns:r="http://schemas.openxmlformats.org/officeDocument/2006/relationships" xmlns:p="http://schemas.openxmlformats.org/presentationml/2006/main">
   <p:cSld>
     <p:spTree>
@@ -11147,7 +11518,7 @@
 </p:sld>
 </file>
 
-<file path=ppt/slides/slide17.xml><?xml version="1.0" encoding="utf-8"?>
+<file path=ppt/slides/slide18.xml><?xml version="1.0" encoding="utf-8"?>
 <p:sld xmlns:a="http://schemas.openxmlformats.org/drawingml/2006/main" xmlns:r="http://schemas.openxmlformats.org/officeDocument/2006/relationships" xmlns:p="http://schemas.openxmlformats.org/presentationml/2006/main">
   <p:cSld>
     <p:spTree>
@@ -11255,7 +11626,7 @@
 </p:sld>
 </file>
 
-<file path=ppt/slides/slide18.xml><?xml version="1.0" encoding="utf-8"?>
+<file path=ppt/slides/slide19.xml><?xml version="1.0" encoding="utf-8"?>
 <p:sld xmlns:a="http://schemas.openxmlformats.org/drawingml/2006/main" xmlns:r="http://schemas.openxmlformats.org/officeDocument/2006/relationships" xmlns:p="http://schemas.openxmlformats.org/presentationml/2006/main">
   <p:cSld>
     <p:spTree>
@@ -11404,383 +11775,6 @@
     <p:extLst>
       <p:ext uri="{BB962C8B-B14F-4D97-AF65-F5344CB8AC3E}">
         <p14:creationId xmlns:p14="http://schemas.microsoft.com/office/powerpoint/2010/main" val="3757480772"/>
-      </p:ext>
-    </p:extLst>
-  </p:cSld>
-  <p:clrMapOvr>
-    <a:masterClrMapping/>
-  </p:clrMapOvr>
-</p:sld>
-</file>
-
-<file path=ppt/slides/slide19.xml><?xml version="1.0" encoding="utf-8"?>
-<p:sld xmlns:a="http://schemas.openxmlformats.org/drawingml/2006/main" xmlns:r="http://schemas.openxmlformats.org/officeDocument/2006/relationships" xmlns:p="http://schemas.openxmlformats.org/presentationml/2006/main">
-  <p:cSld>
-    <p:spTree>
-      <p:nvGrpSpPr>
-        <p:cNvPr id="1" name="">
-          <a:extLst>
-            <a:ext uri="{FF2B5EF4-FFF2-40B4-BE49-F238E27FC236}">
-              <a16:creationId xmlns:a16="http://schemas.microsoft.com/office/drawing/2014/main" id="{94B7ABF1-932F-B975-B6E6-09C4AC18624E}"/>
-            </a:ext>
-          </a:extLst>
-        </p:cNvPr>
-        <p:cNvGrpSpPr/>
-        <p:nvPr/>
-      </p:nvGrpSpPr>
-      <p:grpSpPr>
-        <a:xfrm>
-          <a:off x="0" y="0"/>
-          <a:ext cx="0" cy="0"/>
-          <a:chOff x="0" y="0"/>
-          <a:chExt cx="0" cy="0"/>
-        </a:xfrm>
-      </p:grpSpPr>
-      <p:sp>
-        <p:nvSpPr>
-          <p:cNvPr id="3" name="Title 2">
-            <a:extLst>
-              <a:ext uri="{FF2B5EF4-FFF2-40B4-BE49-F238E27FC236}">
-                <a16:creationId xmlns:a16="http://schemas.microsoft.com/office/drawing/2014/main" id="{B296C1F0-8130-0A43-3A0C-08EAC1726D49}"/>
-              </a:ext>
-            </a:extLst>
-          </p:cNvPr>
-          <p:cNvSpPr>
-            <a:spLocks noGrp="1"/>
-          </p:cNvSpPr>
-          <p:nvPr>
-            <p:ph type="title"/>
-          </p:nvPr>
-        </p:nvSpPr>
-        <p:spPr/>
-        <p:txBody>
-          <a:bodyPr>
-            <a:normAutofit/>
-          </a:bodyPr>
-          <a:lstStyle/>
-          <a:p>
-            <a:r>
-              <a:rPr lang="en-US" sz="5400" b="1" dirty="0">
-                <a:solidFill>
-                  <a:srgbClr val="002060"/>
-                </a:solidFill>
-                <a:latin typeface="Segoe UI" panose="020B0502040204020203" pitchFamily="34" charset="0"/>
-                <a:cs typeface="Segoe UI" panose="020B0502040204020203" pitchFamily="34" charset="0"/>
-              </a:rPr>
-              <a:t>Challenge #5</a:t>
-            </a:r>
-            <a:endParaRPr lang="en-US" sz="3200" b="1" dirty="0">
-              <a:solidFill>
-                <a:srgbClr val="7030A0"/>
-              </a:solidFill>
-              <a:latin typeface="Segoe UI" panose="020B0502040204020203" pitchFamily="34" charset="0"/>
-              <a:cs typeface="Segoe UI" panose="020B0502040204020203" pitchFamily="34" charset="0"/>
-            </a:endParaRPr>
-          </a:p>
-        </p:txBody>
-      </p:sp>
-      <p:sp>
-        <p:nvSpPr>
-          <p:cNvPr id="2" name="Text Placeholder 1">
-            <a:extLst>
-              <a:ext uri="{FF2B5EF4-FFF2-40B4-BE49-F238E27FC236}">
-                <a16:creationId xmlns:a16="http://schemas.microsoft.com/office/drawing/2014/main" id="{3CE059E3-807D-FBB8-62E7-9420CCAFE5E1}"/>
-              </a:ext>
-            </a:extLst>
-          </p:cNvPr>
-          <p:cNvSpPr>
-            <a:spLocks noGrp="1"/>
-          </p:cNvSpPr>
-          <p:nvPr>
-            <p:ph idx="1"/>
-          </p:nvPr>
-        </p:nvSpPr>
-        <p:spPr/>
-        <p:txBody>
-          <a:bodyPr>
-            <a:noAutofit/>
-          </a:bodyPr>
-          <a:lstStyle/>
-          <a:p>
-            <a:pPr marL="0" indent="0">
-              <a:buNone/>
-            </a:pPr>
-            <a:r>
-              <a:rPr lang="en-US" sz="2200" dirty="0">
-                <a:latin typeface="Segoe UI" panose="020B0502040204020203" pitchFamily="34" charset="0"/>
-                <a:cs typeface="Segoe UI" panose="020B0502040204020203" pitchFamily="34" charset="0"/>
-              </a:rPr>
-              <a:t>Your goal is to build a comprehensive monitoring solution for </a:t>
-            </a:r>
-            <a:r>
-              <a:rPr lang="en-US" sz="2200" dirty="0" err="1">
-                <a:latin typeface="Segoe UI" panose="020B0502040204020203" pitchFamily="34" charset="0"/>
-                <a:cs typeface="Segoe UI" panose="020B0502040204020203" pitchFamily="34" charset="0"/>
-              </a:rPr>
-              <a:t>WanderAI</a:t>
-            </a:r>
-            <a:r>
-              <a:rPr lang="en-US" sz="2200" dirty="0">
-                <a:latin typeface="Segoe UI" panose="020B0502040204020203" pitchFamily="34" charset="0"/>
-                <a:cs typeface="Segoe UI" panose="020B0502040204020203" pitchFamily="34" charset="0"/>
-              </a:rPr>
-              <a:t> that includes dashboards, alerts, and meaningful metrics collection.</a:t>
-            </a:r>
-          </a:p>
-          <a:p>
-            <a:pPr marL="457200">
-              <a:lnSpc>
-                <a:spcPct val="110000"/>
-              </a:lnSpc>
-            </a:pPr>
-            <a:r>
-              <a:rPr lang="en-US" sz="2200" b="1" dirty="0">
-                <a:solidFill>
-                  <a:srgbClr val="F6C243"/>
-                </a:solidFill>
-              </a:rPr>
-              <a:t>Enhanced Metrics Collection</a:t>
-            </a:r>
-          </a:p>
-          <a:p>
-            <a:pPr marL="914400" lvl="1">
-              <a:lnSpc>
-                <a:spcPct val="110000"/>
-              </a:lnSpc>
-            </a:pPr>
-            <a:r>
-              <a:rPr lang="en-US" sz="2200" dirty="0"/>
-              <a:t>Add custom metrics to your application using the </a:t>
-            </a:r>
-            <a:r>
-              <a:rPr lang="en-US" sz="2200" dirty="0" err="1"/>
-              <a:t>OpenTelemetry</a:t>
-            </a:r>
-            <a:r>
-              <a:rPr lang="en-US" sz="2200" dirty="0"/>
-              <a:t> meter</a:t>
-            </a:r>
-            <a:endParaRPr lang="en-US" sz="1600" dirty="0"/>
-          </a:p>
-          <a:p>
-            <a:pPr marL="914400" lvl="1">
-              <a:lnSpc>
-                <a:spcPct val="110000"/>
-              </a:lnSpc>
-            </a:pPr>
-            <a:r>
-              <a:rPr lang="en-US" sz="2200" dirty="0"/>
-              <a:t>Emit these metrics from your application code at appropriate points (request handlers, error handlers, tool functions).</a:t>
-            </a:r>
-          </a:p>
-          <a:p>
-            <a:pPr marL="457200">
-              <a:lnSpc>
-                <a:spcPct val="110000"/>
-              </a:lnSpc>
-            </a:pPr>
-            <a:r>
-              <a:rPr lang="en-US" sz="2200" b="1" dirty="0">
-                <a:solidFill>
-                  <a:srgbClr val="F6C243"/>
-                </a:solidFill>
-              </a:rPr>
-              <a:t>Create a New Relic Dashboard</a:t>
-            </a:r>
-          </a:p>
-          <a:p>
-            <a:pPr marL="914400" lvl="1">
-              <a:lnSpc>
-                <a:spcPct val="110000"/>
-              </a:lnSpc>
-            </a:pPr>
-            <a:r>
-              <a:rPr lang="en-US" sz="2200" dirty="0"/>
-              <a:t>Build a dashboard in New Relic called "</a:t>
-            </a:r>
-            <a:r>
-              <a:rPr lang="en-US" sz="2200" dirty="0" err="1"/>
-              <a:t>WanderAI</a:t>
-            </a:r>
-            <a:r>
-              <a:rPr lang="en-US" sz="2200" dirty="0"/>
-              <a:t> Agent Performance”</a:t>
-            </a:r>
-          </a:p>
-          <a:p>
-            <a:pPr marL="914400" lvl="1">
-              <a:lnSpc>
-                <a:spcPct val="110000"/>
-              </a:lnSpc>
-            </a:pPr>
-            <a:r>
-              <a:rPr lang="en-US" sz="2200" dirty="0"/>
-              <a:t>Use NRQL queries to power your dashboard widgets.</a:t>
-            </a:r>
-          </a:p>
-          <a:p>
-            <a:pPr marL="457200">
-              <a:lnSpc>
-                <a:spcPct val="110000"/>
-              </a:lnSpc>
-            </a:pPr>
-            <a:r>
-              <a:rPr lang="en-US" sz="2200" b="1" dirty="0">
-                <a:solidFill>
-                  <a:srgbClr val="F6C243"/>
-                </a:solidFill>
-              </a:rPr>
-              <a:t>Set Up Alerts</a:t>
-            </a:r>
-          </a:p>
-          <a:p>
-            <a:pPr marL="914400" lvl="1">
-              <a:lnSpc>
-                <a:spcPct val="110000"/>
-              </a:lnSpc>
-            </a:pPr>
-            <a:r>
-              <a:rPr lang="en-US" sz="2200" dirty="0"/>
-              <a:t>Configure alerts in New Relic to notify your team</a:t>
-            </a:r>
-          </a:p>
-        </p:txBody>
-      </p:sp>
-      <p:sp>
-        <p:nvSpPr>
-          <p:cNvPr id="8" name="Text Placeholder 7">
-            <a:extLst>
-              <a:ext uri="{FF2B5EF4-FFF2-40B4-BE49-F238E27FC236}">
-                <a16:creationId xmlns:a16="http://schemas.microsoft.com/office/drawing/2014/main" id="{6D89DEEE-2D43-E976-B7A6-2442F5CA34E0}"/>
-              </a:ext>
-            </a:extLst>
-          </p:cNvPr>
-          <p:cNvSpPr>
-            <a:spLocks noGrp="1"/>
-          </p:cNvSpPr>
-          <p:nvPr>
-            <p:ph type="body" sz="quarter" idx="13"/>
-          </p:nvPr>
-        </p:nvSpPr>
-        <p:spPr>
-          <a:xfrm>
-            <a:off x="491704" y="903894"/>
-            <a:ext cx="11373193" cy="614362"/>
-          </a:xfrm>
-        </p:spPr>
-        <p:txBody>
-          <a:bodyPr>
-            <a:noAutofit/>
-          </a:bodyPr>
-          <a:lstStyle/>
-          <a:p>
-            <a:r>
-              <a:rPr lang="en-US" dirty="0"/>
-              <a:t>Optimize for Production - Make it fast, reliable, insightful.</a:t>
-            </a:r>
-          </a:p>
-        </p:txBody>
-      </p:sp>
-      <p:sp>
-        <p:nvSpPr>
-          <p:cNvPr id="4" name="TextBox 3">
-            <a:extLst>
-              <a:ext uri="{FF2B5EF4-FFF2-40B4-BE49-F238E27FC236}">
-                <a16:creationId xmlns:a16="http://schemas.microsoft.com/office/drawing/2014/main" id="{B836436C-7549-DAFC-42F6-3680000E2D4B}"/>
-              </a:ext>
-            </a:extLst>
-          </p:cNvPr>
-          <p:cNvSpPr txBox="1"/>
-          <p:nvPr/>
-        </p:nvSpPr>
-        <p:spPr>
-          <a:xfrm>
-            <a:off x="5034987" y="1307939"/>
-            <a:ext cx="184731" cy="369332"/>
-          </a:xfrm>
-          <a:prstGeom prst="rect">
-            <a:avLst/>
-          </a:prstGeom>
-          <a:noFill/>
-        </p:spPr>
-        <p:txBody>
-          <a:bodyPr wrap="none" rtlCol="0">
-            <a:spAutoFit/>
-          </a:bodyPr>
-          <a:lstStyle/>
-          <a:p>
-            <a:endParaRPr lang="en-US" dirty="0"/>
-          </a:p>
-        </p:txBody>
-      </p:sp>
-      <p:sp>
-        <p:nvSpPr>
-          <p:cNvPr id="6" name="TextBox 5">
-            <a:extLst>
-              <a:ext uri="{FF2B5EF4-FFF2-40B4-BE49-F238E27FC236}">
-                <a16:creationId xmlns:a16="http://schemas.microsoft.com/office/drawing/2014/main" id="{8B25467A-1FCB-8561-66E5-6DE87777547D}"/>
-              </a:ext>
-            </a:extLst>
-          </p:cNvPr>
-          <p:cNvSpPr txBox="1"/>
-          <p:nvPr/>
-        </p:nvSpPr>
-        <p:spPr>
-          <a:xfrm>
-            <a:off x="5775767" y="1088020"/>
-            <a:ext cx="184731" cy="369332"/>
-          </a:xfrm>
-          <a:prstGeom prst="rect">
-            <a:avLst/>
-          </a:prstGeom>
-          <a:noFill/>
-        </p:spPr>
-        <p:txBody>
-          <a:bodyPr wrap="none" rtlCol="0">
-            <a:spAutoFit/>
-          </a:bodyPr>
-          <a:lstStyle/>
-          <a:p>
-            <a:endParaRPr lang="en-US" dirty="0"/>
-          </a:p>
-        </p:txBody>
-      </p:sp>
-      <p:sp>
-        <p:nvSpPr>
-          <p:cNvPr id="7" name="TextBox 6">
-            <a:extLst>
-              <a:ext uri="{FF2B5EF4-FFF2-40B4-BE49-F238E27FC236}">
-                <a16:creationId xmlns:a16="http://schemas.microsoft.com/office/drawing/2014/main" id="{9083AC07-CCFF-507B-0569-2D495A9631B1}"/>
-              </a:ext>
-            </a:extLst>
-          </p:cNvPr>
-          <p:cNvSpPr txBox="1"/>
-          <p:nvPr/>
-        </p:nvSpPr>
-        <p:spPr>
-          <a:xfrm>
-            <a:off x="6111433" y="1157468"/>
-            <a:ext cx="184731" cy="369332"/>
-          </a:xfrm>
-          <a:prstGeom prst="rect">
-            <a:avLst/>
-          </a:prstGeom>
-          <a:noFill/>
-        </p:spPr>
-        <p:txBody>
-          <a:bodyPr wrap="none" rtlCol="0">
-            <a:spAutoFit/>
-          </a:bodyPr>
-          <a:lstStyle/>
-          <a:p>
-            <a:endParaRPr lang="en-US" dirty="0"/>
-          </a:p>
-        </p:txBody>
-      </p:sp>
-    </p:spTree>
-    <p:extLst>
-      <p:ext uri="{BB962C8B-B14F-4D97-AF65-F5344CB8AC3E}">
-        <p14:creationId xmlns:p14="http://schemas.microsoft.com/office/powerpoint/2010/main" val="825295033"/>
       </p:ext>
     </p:extLst>
   </p:cSld>
@@ -12095,6 +12089,383 @@
         <p:cNvPr id="1" name="">
           <a:extLst>
             <a:ext uri="{FF2B5EF4-FFF2-40B4-BE49-F238E27FC236}">
+              <a16:creationId xmlns:a16="http://schemas.microsoft.com/office/drawing/2014/main" id="{94B7ABF1-932F-B975-B6E6-09C4AC18624E}"/>
+            </a:ext>
+          </a:extLst>
+        </p:cNvPr>
+        <p:cNvGrpSpPr/>
+        <p:nvPr/>
+      </p:nvGrpSpPr>
+      <p:grpSpPr>
+        <a:xfrm>
+          <a:off x="0" y="0"/>
+          <a:ext cx="0" cy="0"/>
+          <a:chOff x="0" y="0"/>
+          <a:chExt cx="0" cy="0"/>
+        </a:xfrm>
+      </p:grpSpPr>
+      <p:sp>
+        <p:nvSpPr>
+          <p:cNvPr id="3" name="Title 2">
+            <a:extLst>
+              <a:ext uri="{FF2B5EF4-FFF2-40B4-BE49-F238E27FC236}">
+                <a16:creationId xmlns:a16="http://schemas.microsoft.com/office/drawing/2014/main" id="{B296C1F0-8130-0A43-3A0C-08EAC1726D49}"/>
+              </a:ext>
+            </a:extLst>
+          </p:cNvPr>
+          <p:cNvSpPr>
+            <a:spLocks noGrp="1"/>
+          </p:cNvSpPr>
+          <p:nvPr>
+            <p:ph type="title"/>
+          </p:nvPr>
+        </p:nvSpPr>
+        <p:spPr/>
+        <p:txBody>
+          <a:bodyPr>
+            <a:normAutofit/>
+          </a:bodyPr>
+          <a:lstStyle/>
+          <a:p>
+            <a:r>
+              <a:rPr lang="en-US" sz="5400" b="1" dirty="0">
+                <a:solidFill>
+                  <a:srgbClr val="002060"/>
+                </a:solidFill>
+                <a:latin typeface="Segoe UI" panose="020B0502040204020203" pitchFamily="34" charset="0"/>
+                <a:cs typeface="Segoe UI" panose="020B0502040204020203" pitchFamily="34" charset="0"/>
+              </a:rPr>
+              <a:t>Challenge #5</a:t>
+            </a:r>
+            <a:endParaRPr lang="en-US" sz="3200" b="1" dirty="0">
+              <a:solidFill>
+                <a:srgbClr val="7030A0"/>
+              </a:solidFill>
+              <a:latin typeface="Segoe UI" panose="020B0502040204020203" pitchFamily="34" charset="0"/>
+              <a:cs typeface="Segoe UI" panose="020B0502040204020203" pitchFamily="34" charset="0"/>
+            </a:endParaRPr>
+          </a:p>
+        </p:txBody>
+      </p:sp>
+      <p:sp>
+        <p:nvSpPr>
+          <p:cNvPr id="2" name="Text Placeholder 1">
+            <a:extLst>
+              <a:ext uri="{FF2B5EF4-FFF2-40B4-BE49-F238E27FC236}">
+                <a16:creationId xmlns:a16="http://schemas.microsoft.com/office/drawing/2014/main" id="{3CE059E3-807D-FBB8-62E7-9420CCAFE5E1}"/>
+              </a:ext>
+            </a:extLst>
+          </p:cNvPr>
+          <p:cNvSpPr>
+            <a:spLocks noGrp="1"/>
+          </p:cNvSpPr>
+          <p:nvPr>
+            <p:ph idx="1"/>
+          </p:nvPr>
+        </p:nvSpPr>
+        <p:spPr/>
+        <p:txBody>
+          <a:bodyPr>
+            <a:noAutofit/>
+          </a:bodyPr>
+          <a:lstStyle/>
+          <a:p>
+            <a:pPr marL="0" indent="0">
+              <a:buNone/>
+            </a:pPr>
+            <a:r>
+              <a:rPr lang="en-US" sz="2200" dirty="0">
+                <a:latin typeface="Segoe UI" panose="020B0502040204020203" pitchFamily="34" charset="0"/>
+                <a:cs typeface="Segoe UI" panose="020B0502040204020203" pitchFamily="34" charset="0"/>
+              </a:rPr>
+              <a:t>Your goal is to build a comprehensive monitoring solution for </a:t>
+            </a:r>
+            <a:r>
+              <a:rPr lang="en-US" sz="2200" dirty="0" err="1">
+                <a:latin typeface="Segoe UI" panose="020B0502040204020203" pitchFamily="34" charset="0"/>
+                <a:cs typeface="Segoe UI" panose="020B0502040204020203" pitchFamily="34" charset="0"/>
+              </a:rPr>
+              <a:t>WanderAI</a:t>
+            </a:r>
+            <a:r>
+              <a:rPr lang="en-US" sz="2200" dirty="0">
+                <a:latin typeface="Segoe UI" panose="020B0502040204020203" pitchFamily="34" charset="0"/>
+                <a:cs typeface="Segoe UI" panose="020B0502040204020203" pitchFamily="34" charset="0"/>
+              </a:rPr>
+              <a:t> that includes dashboards, alerts, and meaningful metrics collection.</a:t>
+            </a:r>
+          </a:p>
+          <a:p>
+            <a:pPr marL="457200">
+              <a:lnSpc>
+                <a:spcPct val="110000"/>
+              </a:lnSpc>
+            </a:pPr>
+            <a:r>
+              <a:rPr lang="en-US" sz="2200" b="1" dirty="0">
+                <a:solidFill>
+                  <a:srgbClr val="F6C243"/>
+                </a:solidFill>
+              </a:rPr>
+              <a:t>Enhanced Metrics Collection</a:t>
+            </a:r>
+          </a:p>
+          <a:p>
+            <a:pPr marL="914400" lvl="1">
+              <a:lnSpc>
+                <a:spcPct val="110000"/>
+              </a:lnSpc>
+            </a:pPr>
+            <a:r>
+              <a:rPr lang="en-US" sz="2200" dirty="0"/>
+              <a:t>Add custom metrics to your application using the </a:t>
+            </a:r>
+            <a:r>
+              <a:rPr lang="en-US" sz="2200" dirty="0" err="1"/>
+              <a:t>OpenTelemetry</a:t>
+            </a:r>
+            <a:r>
+              <a:rPr lang="en-US" sz="2200" dirty="0"/>
+              <a:t> meter</a:t>
+            </a:r>
+            <a:endParaRPr lang="en-US" sz="1600" dirty="0"/>
+          </a:p>
+          <a:p>
+            <a:pPr marL="914400" lvl="1">
+              <a:lnSpc>
+                <a:spcPct val="110000"/>
+              </a:lnSpc>
+            </a:pPr>
+            <a:r>
+              <a:rPr lang="en-US" sz="2200" dirty="0"/>
+              <a:t>Emit these metrics from your application code at appropriate points (request handlers, error handlers, tool functions).</a:t>
+            </a:r>
+          </a:p>
+          <a:p>
+            <a:pPr marL="457200">
+              <a:lnSpc>
+                <a:spcPct val="110000"/>
+              </a:lnSpc>
+            </a:pPr>
+            <a:r>
+              <a:rPr lang="en-US" sz="2200" b="1" dirty="0">
+                <a:solidFill>
+                  <a:srgbClr val="F6C243"/>
+                </a:solidFill>
+              </a:rPr>
+              <a:t>Create a New Relic Dashboard</a:t>
+            </a:r>
+          </a:p>
+          <a:p>
+            <a:pPr marL="914400" lvl="1">
+              <a:lnSpc>
+                <a:spcPct val="110000"/>
+              </a:lnSpc>
+            </a:pPr>
+            <a:r>
+              <a:rPr lang="en-US" sz="2200" dirty="0"/>
+              <a:t>Build a dashboard in New Relic called "</a:t>
+            </a:r>
+            <a:r>
+              <a:rPr lang="en-US" sz="2200" dirty="0" err="1"/>
+              <a:t>WanderAI</a:t>
+            </a:r>
+            <a:r>
+              <a:rPr lang="en-US" sz="2200" dirty="0"/>
+              <a:t> Agent Performance”</a:t>
+            </a:r>
+          </a:p>
+          <a:p>
+            <a:pPr marL="914400" lvl="1">
+              <a:lnSpc>
+                <a:spcPct val="110000"/>
+              </a:lnSpc>
+            </a:pPr>
+            <a:r>
+              <a:rPr lang="en-US" sz="2200" dirty="0"/>
+              <a:t>Use NRQL queries to power your dashboard widgets.</a:t>
+            </a:r>
+          </a:p>
+          <a:p>
+            <a:pPr marL="457200">
+              <a:lnSpc>
+                <a:spcPct val="110000"/>
+              </a:lnSpc>
+            </a:pPr>
+            <a:r>
+              <a:rPr lang="en-US" sz="2200" b="1" dirty="0">
+                <a:solidFill>
+                  <a:srgbClr val="F6C243"/>
+                </a:solidFill>
+              </a:rPr>
+              <a:t>Set Up Alerts</a:t>
+            </a:r>
+          </a:p>
+          <a:p>
+            <a:pPr marL="914400" lvl="1">
+              <a:lnSpc>
+                <a:spcPct val="110000"/>
+              </a:lnSpc>
+            </a:pPr>
+            <a:r>
+              <a:rPr lang="en-US" sz="2200" dirty="0"/>
+              <a:t>Configure alerts in New Relic to notify your team</a:t>
+            </a:r>
+          </a:p>
+        </p:txBody>
+      </p:sp>
+      <p:sp>
+        <p:nvSpPr>
+          <p:cNvPr id="8" name="Text Placeholder 7">
+            <a:extLst>
+              <a:ext uri="{FF2B5EF4-FFF2-40B4-BE49-F238E27FC236}">
+                <a16:creationId xmlns:a16="http://schemas.microsoft.com/office/drawing/2014/main" id="{6D89DEEE-2D43-E976-B7A6-2442F5CA34E0}"/>
+              </a:ext>
+            </a:extLst>
+          </p:cNvPr>
+          <p:cNvSpPr>
+            <a:spLocks noGrp="1"/>
+          </p:cNvSpPr>
+          <p:nvPr>
+            <p:ph type="body" sz="quarter" idx="13"/>
+          </p:nvPr>
+        </p:nvSpPr>
+        <p:spPr>
+          <a:xfrm>
+            <a:off x="491704" y="903894"/>
+            <a:ext cx="11373193" cy="614362"/>
+          </a:xfrm>
+        </p:spPr>
+        <p:txBody>
+          <a:bodyPr>
+            <a:noAutofit/>
+          </a:bodyPr>
+          <a:lstStyle/>
+          <a:p>
+            <a:r>
+              <a:rPr lang="en-US" dirty="0"/>
+              <a:t>Optimize for Production - Make it fast, reliable, insightful.</a:t>
+            </a:r>
+          </a:p>
+        </p:txBody>
+      </p:sp>
+      <p:sp>
+        <p:nvSpPr>
+          <p:cNvPr id="4" name="TextBox 3">
+            <a:extLst>
+              <a:ext uri="{FF2B5EF4-FFF2-40B4-BE49-F238E27FC236}">
+                <a16:creationId xmlns:a16="http://schemas.microsoft.com/office/drawing/2014/main" id="{B836436C-7549-DAFC-42F6-3680000E2D4B}"/>
+              </a:ext>
+            </a:extLst>
+          </p:cNvPr>
+          <p:cNvSpPr txBox="1"/>
+          <p:nvPr/>
+        </p:nvSpPr>
+        <p:spPr>
+          <a:xfrm>
+            <a:off x="5034987" y="1307939"/>
+            <a:ext cx="184731" cy="369332"/>
+          </a:xfrm>
+          <a:prstGeom prst="rect">
+            <a:avLst/>
+          </a:prstGeom>
+          <a:noFill/>
+        </p:spPr>
+        <p:txBody>
+          <a:bodyPr wrap="none" rtlCol="0">
+            <a:spAutoFit/>
+          </a:bodyPr>
+          <a:lstStyle/>
+          <a:p>
+            <a:endParaRPr lang="en-US" dirty="0"/>
+          </a:p>
+        </p:txBody>
+      </p:sp>
+      <p:sp>
+        <p:nvSpPr>
+          <p:cNvPr id="6" name="TextBox 5">
+            <a:extLst>
+              <a:ext uri="{FF2B5EF4-FFF2-40B4-BE49-F238E27FC236}">
+                <a16:creationId xmlns:a16="http://schemas.microsoft.com/office/drawing/2014/main" id="{8B25467A-1FCB-8561-66E5-6DE87777547D}"/>
+              </a:ext>
+            </a:extLst>
+          </p:cNvPr>
+          <p:cNvSpPr txBox="1"/>
+          <p:nvPr/>
+        </p:nvSpPr>
+        <p:spPr>
+          <a:xfrm>
+            <a:off x="5775767" y="1088020"/>
+            <a:ext cx="184731" cy="369332"/>
+          </a:xfrm>
+          <a:prstGeom prst="rect">
+            <a:avLst/>
+          </a:prstGeom>
+          <a:noFill/>
+        </p:spPr>
+        <p:txBody>
+          <a:bodyPr wrap="none" rtlCol="0">
+            <a:spAutoFit/>
+          </a:bodyPr>
+          <a:lstStyle/>
+          <a:p>
+            <a:endParaRPr lang="en-US" dirty="0"/>
+          </a:p>
+        </p:txBody>
+      </p:sp>
+      <p:sp>
+        <p:nvSpPr>
+          <p:cNvPr id="7" name="TextBox 6">
+            <a:extLst>
+              <a:ext uri="{FF2B5EF4-FFF2-40B4-BE49-F238E27FC236}">
+                <a16:creationId xmlns:a16="http://schemas.microsoft.com/office/drawing/2014/main" id="{9083AC07-CCFF-507B-0569-2D495A9631B1}"/>
+              </a:ext>
+            </a:extLst>
+          </p:cNvPr>
+          <p:cNvSpPr txBox="1"/>
+          <p:nvPr/>
+        </p:nvSpPr>
+        <p:spPr>
+          <a:xfrm>
+            <a:off x="6111433" y="1157468"/>
+            <a:ext cx="184731" cy="369332"/>
+          </a:xfrm>
+          <a:prstGeom prst="rect">
+            <a:avLst/>
+          </a:prstGeom>
+          <a:noFill/>
+        </p:spPr>
+        <p:txBody>
+          <a:bodyPr wrap="none" rtlCol="0">
+            <a:spAutoFit/>
+          </a:bodyPr>
+          <a:lstStyle/>
+          <a:p>
+            <a:endParaRPr lang="en-US" dirty="0"/>
+          </a:p>
+        </p:txBody>
+      </p:sp>
+    </p:spTree>
+    <p:extLst>
+      <p:ext uri="{BB962C8B-B14F-4D97-AF65-F5344CB8AC3E}">
+        <p14:creationId xmlns:p14="http://schemas.microsoft.com/office/powerpoint/2010/main" val="825295033"/>
+      </p:ext>
+    </p:extLst>
+  </p:cSld>
+  <p:clrMapOvr>
+    <a:masterClrMapping/>
+  </p:clrMapOvr>
+</p:sld>
+</file>
+
+<file path=ppt/slides/slide21.xml><?xml version="1.0" encoding="utf-8"?>
+<p:sld xmlns:a="http://schemas.openxmlformats.org/drawingml/2006/main" xmlns:r="http://schemas.openxmlformats.org/officeDocument/2006/relationships" xmlns:p="http://schemas.openxmlformats.org/presentationml/2006/main">
+  <p:cSld>
+    <p:spTree>
+      <p:nvGrpSpPr>
+        <p:cNvPr id="1" name="">
+          <a:extLst>
+            <a:ext uri="{FF2B5EF4-FFF2-40B4-BE49-F238E27FC236}">
               <a16:creationId xmlns:a16="http://schemas.microsoft.com/office/drawing/2014/main" id="{26A93CB8-4CCA-6100-92C1-9717FB182B26}"/>
             </a:ext>
           </a:extLst>
@@ -12195,7 +12566,7 @@
 </p:sld>
 </file>
 
-<file path=ppt/slides/slide21.xml><?xml version="1.0" encoding="utf-8"?>
+<file path=ppt/slides/slide22.xml><?xml version="1.0" encoding="utf-8"?>
 <p:sld xmlns:a="http://schemas.openxmlformats.org/drawingml/2006/main" xmlns:r="http://schemas.openxmlformats.org/officeDocument/2006/relationships" xmlns:p="http://schemas.openxmlformats.org/presentationml/2006/main">
   <p:cSld>
     <p:spTree>
@@ -12347,7 +12718,7 @@
 </p:sld>
 </file>
 
-<file path=ppt/slides/slide22.xml><?xml version="1.0" encoding="utf-8"?>
+<file path=ppt/slides/slide23.xml><?xml version="1.0" encoding="utf-8"?>
 <p:sld xmlns:a="http://schemas.openxmlformats.org/drawingml/2006/main" xmlns:r="http://schemas.openxmlformats.org/officeDocument/2006/relationships" xmlns:p="http://schemas.openxmlformats.org/presentationml/2006/main">
   <p:cSld>
     <p:spTree>
@@ -12734,7 +13105,7 @@
 </p:sld>
 </file>
 
-<file path=ppt/slides/slide23.xml><?xml version="1.0" encoding="utf-8"?>
+<file path=ppt/slides/slide24.xml><?xml version="1.0" encoding="utf-8"?>
 <p:sld xmlns:a="http://schemas.openxmlformats.org/drawingml/2006/main" xmlns:r="http://schemas.openxmlformats.org/officeDocument/2006/relationships" xmlns:p="http://schemas.openxmlformats.org/presentationml/2006/main">
   <p:cSld>
     <p:spTree>
@@ -12843,7 +13214,7 @@
 </p:sld>
 </file>
 
-<file path=ppt/slides/slide24.xml><?xml version="1.0" encoding="utf-8"?>
+<file path=ppt/slides/slide25.xml><?xml version="1.0" encoding="utf-8"?>
 <p:sld xmlns:a="http://schemas.openxmlformats.org/drawingml/2006/main" xmlns:r="http://schemas.openxmlformats.org/officeDocument/2006/relationships" xmlns:p="http://schemas.openxmlformats.org/presentationml/2006/main">
   <p:cSld>
     <p:spTree>
@@ -13104,7 +13475,7 @@
 </p:sld>
 </file>
 
-<file path=ppt/slides/slide25.xml><?xml version="1.0" encoding="utf-8"?>
+<file path=ppt/slides/slide26.xml><?xml version="1.0" encoding="utf-8"?>
 <p:sld xmlns:a="http://schemas.openxmlformats.org/drawingml/2006/main" xmlns:r="http://schemas.openxmlformats.org/officeDocument/2006/relationships" xmlns:p="http://schemas.openxmlformats.org/presentationml/2006/main">
   <p:cSld>
     <p:spTree>
@@ -13493,7 +13864,7 @@
 </p:sld>
 </file>
 
-<file path=ppt/slides/slide26.xml><?xml version="1.0" encoding="utf-8"?>
+<file path=ppt/slides/slide27.xml><?xml version="1.0" encoding="utf-8"?>
 <p:sld xmlns:a="http://schemas.openxmlformats.org/drawingml/2006/main" xmlns:r="http://schemas.openxmlformats.org/officeDocument/2006/relationships" xmlns:p="http://schemas.openxmlformats.org/presentationml/2006/main">
   <p:cSld>
     <p:bg>
@@ -13904,8 +14275,8 @@
         </p:nvSpPr>
         <p:spPr>
           <a:xfrm>
-            <a:off x="895552" y="3952220"/>
-            <a:ext cx="3338286" cy="461665"/>
+            <a:off x="830729" y="3952220"/>
+            <a:ext cx="3403109" cy="461665"/>
           </a:xfrm>
           <a:prstGeom prst="rect">
             <a:avLst/>
@@ -14016,7 +14387,7 @@
                 <a:ea typeface="+mn-ea"/>
                 <a:cs typeface="Segoe UI" panose="020B0502040204020203" pitchFamily="34" charset="0"/>
               </a:rPr>
-              <a:t>&lt;Coach Name&gt;</a:t>
+              <a:t>Peter Laudati</a:t>
             </a:r>
           </a:p>
         </p:txBody>
@@ -14035,8 +14406,8 @@
         </p:nvSpPr>
         <p:spPr>
           <a:xfrm>
-            <a:off x="7854137" y="3977973"/>
-            <a:ext cx="3338286" cy="461665"/>
+            <a:off x="7854136" y="3977973"/>
+            <a:ext cx="3507135" cy="461665"/>
           </a:xfrm>
           <a:prstGeom prst="rect">
             <a:avLst/>
@@ -14082,7 +14453,7 @@
                 <a:latin typeface="Segoe UI" panose="020B0502040204020203" pitchFamily="34" charset="0"/>
                 <a:cs typeface="Segoe UI" panose="020B0502040204020203" pitchFamily="34" charset="0"/>
               </a:rPr>
-              <a:t>&lt;Coach Title&gt;</a:t>
+              <a:t>Cloud SA @ MSFT</a:t>
             </a:r>
           </a:p>
         </p:txBody>
@@ -14147,7 +14518,7 @@
                 <a:ea typeface="+mn-ea"/>
                 <a:cs typeface="Segoe UI" panose="020B0502040204020203" pitchFamily="34" charset="0"/>
               </a:rPr>
-              <a:t>&lt;Coach Name&gt;</a:t>
+              <a:t>Spence Taylor</a:t>
             </a:r>
           </a:p>
         </p:txBody>
@@ -14166,8 +14537,8 @@
         </p:nvSpPr>
         <p:spPr>
           <a:xfrm>
-            <a:off x="895552" y="5108875"/>
-            <a:ext cx="3338286" cy="461665"/>
+            <a:off x="830729" y="5108875"/>
+            <a:ext cx="3403109" cy="461665"/>
           </a:xfrm>
           <a:prstGeom prst="rect">
             <a:avLst/>
@@ -14175,6 +14546,50 @@
           <a:solidFill>
             <a:srgbClr val="7030A0"/>
           </a:solidFill>
+        </p:spPr>
+        <p:txBody>
+          <a:bodyPr wrap="square" rtlCol="0">
+            <a:spAutoFit/>
+          </a:bodyPr>
+          <a:lstStyle/>
+          <a:p>
+            <a:pPr lvl="0" algn="ctr">
+              <a:defRPr/>
+            </a:pPr>
+            <a:r>
+              <a:rPr lang="en-US" sz="2400" dirty="0">
+                <a:solidFill>
+                  <a:srgbClr val="FFFF00"/>
+                </a:solidFill>
+                <a:latin typeface="Segoe UI" panose="020B0502040204020203" pitchFamily="34" charset="0"/>
+                <a:cs typeface="Segoe UI" panose="020B0502040204020203" pitchFamily="34" charset="0"/>
+              </a:rPr>
+              <a:t>DevRel @ New Relic</a:t>
+            </a:r>
+          </a:p>
+        </p:txBody>
+      </p:sp>
+      <p:sp>
+        <p:nvSpPr>
+          <p:cNvPr id="2" name="TextBox 1">
+            <a:extLst>
+              <a:ext uri="{FF2B5EF4-FFF2-40B4-BE49-F238E27FC236}">
+                <a16:creationId xmlns:a16="http://schemas.microsoft.com/office/drawing/2014/main" id="{B5A92C3D-FD94-4F13-B142-E7743BE77A67}"/>
+              </a:ext>
+            </a:extLst>
+          </p:cNvPr>
+          <p:cNvSpPr txBox="1"/>
+          <p:nvPr/>
+        </p:nvSpPr>
+        <p:spPr>
+          <a:xfrm>
+            <a:off x="7505794" y="4585655"/>
+            <a:ext cx="4005942" cy="523220"/>
+          </a:xfrm>
+          <a:prstGeom prst="rect">
+            <a:avLst/>
+          </a:prstGeom>
+          <a:noFill/>
         </p:spPr>
         <p:txBody>
           <a:bodyPr wrap="square" rtlCol="0">
@@ -14200,30 +14615,31 @@
               <a:defRPr/>
             </a:pPr>
             <a:r>
-              <a:rPr kumimoji="0" lang="en-US" sz="2400" b="0" i="0" u="none" strike="noStrike" kern="1200" cap="none" spc="0" normalizeH="0" baseline="0" noProof="0" dirty="0">
+              <a:rPr kumimoji="0" lang="en-US" sz="2800" b="1" i="0" u="none" strike="noStrike" kern="1200" cap="none" spc="0" normalizeH="0" baseline="0" noProof="0" dirty="0">
                 <a:ln>
                   <a:noFill/>
                 </a:ln>
                 <a:solidFill>
-                  <a:srgbClr val="FFFF00"/>
+                  <a:prstClr val="black"/>
                 </a:solidFill>
                 <a:effectLst/>
                 <a:uLnTx/>
                 <a:uFillTx/>
                 <a:latin typeface="Segoe UI" panose="020B0502040204020203" pitchFamily="34" charset="0"/>
+                <a:ea typeface="+mn-ea"/>
                 <a:cs typeface="Segoe UI" panose="020B0502040204020203" pitchFamily="34" charset="0"/>
               </a:rPr>
-              <a:t>&lt;Coach Title&gt;</a:t>
-            </a:r>
-          </a:p>
-        </p:txBody>
-      </p:sp>
-      <p:sp>
-        <p:nvSpPr>
-          <p:cNvPr id="2" name="TextBox 1">
-            <a:extLst>
-              <a:ext uri="{FF2B5EF4-FFF2-40B4-BE49-F238E27FC236}">
-                <a16:creationId xmlns:a16="http://schemas.microsoft.com/office/drawing/2014/main" id="{B5A92C3D-FD94-4F13-B142-E7743BE77A67}"/>
+              <a:t>Andy Huang</a:t>
+            </a:r>
+          </a:p>
+        </p:txBody>
+      </p:sp>
+      <p:sp>
+        <p:nvSpPr>
+          <p:cNvPr id="4" name="TextBox 3">
+            <a:extLst>
+              <a:ext uri="{FF2B5EF4-FFF2-40B4-BE49-F238E27FC236}">
+                <a16:creationId xmlns:a16="http://schemas.microsoft.com/office/drawing/2014/main" id="{5D18A1DD-2BF8-4974-92EB-55948F02856B}"/>
               </a:ext>
             </a:extLst>
           </p:cNvPr>
@@ -14232,7 +14648,53 @@
         </p:nvSpPr>
         <p:spPr>
           <a:xfrm>
-            <a:off x="7505794" y="4585655"/>
+            <a:off x="7854136" y="5108875"/>
+            <a:ext cx="3507135" cy="461665"/>
+          </a:xfrm>
+          <a:prstGeom prst="rect">
+            <a:avLst/>
+          </a:prstGeom>
+          <a:solidFill>
+            <a:srgbClr val="7030A0"/>
+          </a:solidFill>
+        </p:spPr>
+        <p:txBody>
+          <a:bodyPr wrap="square" rtlCol="0">
+            <a:spAutoFit/>
+          </a:bodyPr>
+          <a:lstStyle/>
+          <a:p>
+            <a:pPr lvl="0" algn="ctr">
+              <a:defRPr/>
+            </a:pPr>
+            <a:r>
+              <a:rPr lang="en-US" sz="2400" dirty="0">
+                <a:solidFill>
+                  <a:srgbClr val="FFFF00"/>
+                </a:solidFill>
+                <a:latin typeface="Segoe UI" panose="020B0502040204020203" pitchFamily="34" charset="0"/>
+                <a:cs typeface="Segoe UI" panose="020B0502040204020203" pitchFamily="34" charset="0"/>
+              </a:rPr>
+              <a:t>Cloud SA @ MSFT</a:t>
+            </a:r>
+          </a:p>
+        </p:txBody>
+      </p:sp>
+      <p:sp>
+        <p:nvSpPr>
+          <p:cNvPr id="5" name="TextBox 4">
+            <a:extLst>
+              <a:ext uri="{FF2B5EF4-FFF2-40B4-BE49-F238E27FC236}">
+                <a16:creationId xmlns:a16="http://schemas.microsoft.com/office/drawing/2014/main" id="{D0E81E37-1AF6-389E-CD4D-F7F94F2CA3A2}"/>
+              </a:ext>
+            </a:extLst>
+          </p:cNvPr>
+          <p:cNvSpPr txBox="1"/>
+          <p:nvPr/>
+        </p:nvSpPr>
+        <p:spPr>
+          <a:xfrm>
+            <a:off x="4091324" y="4036682"/>
             <a:ext cx="4005942" cy="523220"/>
           </a:xfrm>
           <a:prstGeom prst="rect">
@@ -14278,17 +14740,48 @@
                 <a:ea typeface="+mn-ea"/>
                 <a:cs typeface="Segoe UI" panose="020B0502040204020203" pitchFamily="34" charset="0"/>
               </a:rPr>
-              <a:t>&lt;Coach Name&gt;</a:t>
-            </a:r>
-          </a:p>
-        </p:txBody>
-      </p:sp>
-      <p:sp>
-        <p:nvSpPr>
-          <p:cNvPr id="4" name="TextBox 3">
-            <a:extLst>
-              <a:ext uri="{FF2B5EF4-FFF2-40B4-BE49-F238E27FC236}">
-                <a16:creationId xmlns:a16="http://schemas.microsoft.com/office/drawing/2014/main" id="{5D18A1DD-2BF8-4974-92EB-55948F02856B}"/>
+              <a:t>Jemiah </a:t>
+            </a:r>
+            <a:r>
+              <a:rPr kumimoji="0" lang="en-US" sz="2800" b="1" i="0" u="none" strike="noStrike" kern="1200" cap="none" spc="0" normalizeH="0" baseline="0" noProof="0" dirty="0" err="1">
+                <a:ln>
+                  <a:noFill/>
+                </a:ln>
+                <a:solidFill>
+                  <a:prstClr val="black"/>
+                </a:solidFill>
+                <a:effectLst/>
+                <a:uLnTx/>
+                <a:uFillTx/>
+                <a:latin typeface="Segoe UI" panose="020B0502040204020203" pitchFamily="34" charset="0"/>
+                <a:ea typeface="+mn-ea"/>
+                <a:cs typeface="Segoe UI" panose="020B0502040204020203" pitchFamily="34" charset="0"/>
+              </a:rPr>
+              <a:t>Sius</a:t>
+            </a:r>
+            <a:endParaRPr kumimoji="0" lang="en-US" sz="2800" b="1" i="0" u="none" strike="noStrike" kern="1200" cap="none" spc="0" normalizeH="0" baseline="0" noProof="0" dirty="0">
+              <a:ln>
+                <a:noFill/>
+              </a:ln>
+              <a:solidFill>
+                <a:prstClr val="black"/>
+              </a:solidFill>
+              <a:effectLst/>
+              <a:uLnTx/>
+              <a:uFillTx/>
+              <a:latin typeface="Segoe UI" panose="020B0502040204020203" pitchFamily="34" charset="0"/>
+              <a:ea typeface="+mn-ea"/>
+              <a:cs typeface="Segoe UI" panose="020B0502040204020203" pitchFamily="34" charset="0"/>
+            </a:endParaRPr>
+          </a:p>
+        </p:txBody>
+      </p:sp>
+      <p:sp>
+        <p:nvSpPr>
+          <p:cNvPr id="9" name="TextBox 8">
+            <a:extLst>
+              <a:ext uri="{FF2B5EF4-FFF2-40B4-BE49-F238E27FC236}">
+                <a16:creationId xmlns:a16="http://schemas.microsoft.com/office/drawing/2014/main" id="{001D4E73-B354-BF96-263D-0D4EB79C3342}"/>
               </a:ext>
             </a:extLst>
           </p:cNvPr>
@@ -14297,8 +14790,8 @@
         </p:nvSpPr>
         <p:spPr>
           <a:xfrm>
-            <a:off x="7854137" y="5108875"/>
-            <a:ext cx="3338286" cy="461665"/>
+            <a:off x="4374844" y="4559902"/>
+            <a:ext cx="3403109" cy="461665"/>
           </a:xfrm>
           <a:prstGeom prst="rect">
             <a:avLst/>
@@ -14313,38 +14806,18 @@
           </a:bodyPr>
           <a:lstStyle/>
           <a:p>
-            <a:pPr marL="0" marR="0" lvl="0" indent="0" algn="ctr" defTabSz="914400" rtl="0" eaLnBrk="1" fontAlgn="auto" latinLnBrk="0" hangingPunct="1">
-              <a:lnSpc>
-                <a:spcPct val="100000"/>
-              </a:lnSpc>
-              <a:spcBef>
-                <a:spcPts val="0"/>
-              </a:spcBef>
-              <a:spcAft>
-                <a:spcPts val="0"/>
-              </a:spcAft>
-              <a:buClrTx/>
-              <a:buSzTx/>
-              <a:buFontTx/>
-              <a:buNone/>
-              <a:tabLst/>
+            <a:pPr lvl="0" algn="ctr">
               <a:defRPr/>
             </a:pPr>
             <a:r>
-              <a:rPr kumimoji="0" lang="en-US" sz="2400" b="0" i="0" u="none" strike="noStrike" kern="1200" cap="none" spc="0" normalizeH="0" baseline="0" noProof="0" dirty="0">
-                <a:ln>
-                  <a:noFill/>
-                </a:ln>
+              <a:rPr lang="en-US" sz="2400" dirty="0">
                 <a:solidFill>
                   <a:srgbClr val="FFFF00"/>
                 </a:solidFill>
-                <a:effectLst/>
-                <a:uLnTx/>
-                <a:uFillTx/>
                 <a:latin typeface="Segoe UI" panose="020B0502040204020203" pitchFamily="34" charset="0"/>
                 <a:cs typeface="Segoe UI" panose="020B0502040204020203" pitchFamily="34" charset="0"/>
               </a:rPr>
-              <a:t>&lt;Coach Title&gt;</a:t>
+              <a:t>DevRel @ New Relic</a:t>
             </a:r>
           </a:p>
         </p:txBody>
@@ -15152,7 +15625,7 @@
         <p:cNvPr id="1" name="">
           <a:extLst>
             <a:ext uri="{FF2B5EF4-FFF2-40B4-BE49-F238E27FC236}">
-              <a16:creationId xmlns:a16="http://schemas.microsoft.com/office/drawing/2014/main" id="{25712C6D-4F42-BAEB-2EFA-7C14789A488F}"/>
+              <a16:creationId xmlns:a16="http://schemas.microsoft.com/office/drawing/2014/main" id="{1B66A7C8-0A8E-E3B7-2371-175617C993A1}"/>
             </a:ext>
           </a:extLst>
         </p:cNvPr>
@@ -15169,10 +15642,10 @@
       </p:grpSpPr>
       <p:sp>
         <p:nvSpPr>
-          <p:cNvPr id="2" name="Title 1">
-            <a:extLst>
-              <a:ext uri="{FF2B5EF4-FFF2-40B4-BE49-F238E27FC236}">
-                <a16:creationId xmlns:a16="http://schemas.microsoft.com/office/drawing/2014/main" id="{D1F0412C-C462-19AF-6F33-CBE9E1B120B0}"/>
+          <p:cNvPr id="3" name="Title 2">
+            <a:extLst>
+              <a:ext uri="{FF2B5EF4-FFF2-40B4-BE49-F238E27FC236}">
+                <a16:creationId xmlns:a16="http://schemas.microsoft.com/office/drawing/2014/main" id="{F7DC16E4-D6D5-3FA6-E9E5-3897C761D003}"/>
               </a:ext>
             </a:extLst>
           </p:cNvPr>
@@ -15181,41 +15654,6 @@
           </p:cNvSpPr>
           <p:nvPr>
             <p:ph type="title"/>
-          </p:nvPr>
-        </p:nvSpPr>
-        <p:spPr/>
-        <p:txBody>
-          <a:bodyPr lIns="90000" anchor="t" anchorCtr="0"/>
-          <a:lstStyle/>
-          <a:p>
-            <a:r>
-              <a:rPr lang="en-US" dirty="0"/>
-              <a:t>Challenge 2</a:t>
-            </a:r>
-            <a:br>
-              <a:rPr lang="en-US" dirty="0"/>
-            </a:br>
-            <a:r>
-              <a:rPr lang="en-US" dirty="0"/>
-              <a:t>- Build Your MVP</a:t>
-            </a:r>
-          </a:p>
-        </p:txBody>
-      </p:sp>
-      <p:sp>
-        <p:nvSpPr>
-          <p:cNvPr id="3" name="Text Placeholder 2">
-            <a:extLst>
-              <a:ext uri="{FF2B5EF4-FFF2-40B4-BE49-F238E27FC236}">
-                <a16:creationId xmlns:a16="http://schemas.microsoft.com/office/drawing/2014/main" id="{0726EB30-B8F0-B4D8-31BD-EFB7D114705F}"/>
-              </a:ext>
-            </a:extLst>
-          </p:cNvPr>
-          <p:cNvSpPr>
-            <a:spLocks noGrp="1"/>
-          </p:cNvSpPr>
-          <p:nvPr>
-            <p:ph type="body" idx="1"/>
           </p:nvPr>
         </p:nvSpPr>
         <p:spPr/>
@@ -15225,26 +15663,189 @@
           </a:bodyPr>
           <a:lstStyle/>
           <a:p>
-            <a:pPr algn="ctr"/>
+            <a:r>
+              <a:rPr lang="en-US" sz="5400" b="1" dirty="0">
+                <a:solidFill>
+                  <a:srgbClr val="002060"/>
+                </a:solidFill>
+                <a:latin typeface="Segoe UI" panose="020B0502040204020203" pitchFamily="34" charset="0"/>
+                <a:cs typeface="Segoe UI" panose="020B0502040204020203" pitchFamily="34" charset="0"/>
+              </a:rPr>
+              <a:t>Challenge #1</a:t>
+            </a:r>
+            <a:endParaRPr lang="en-US" sz="3200" b="1" dirty="0">
+              <a:solidFill>
+                <a:srgbClr val="7030A0"/>
+              </a:solidFill>
+              <a:latin typeface="Segoe UI" panose="020B0502040204020203" pitchFamily="34" charset="0"/>
+              <a:cs typeface="Segoe UI" panose="020B0502040204020203" pitchFamily="34" charset="0"/>
+            </a:endParaRPr>
+          </a:p>
+        </p:txBody>
+      </p:sp>
+      <p:sp>
+        <p:nvSpPr>
+          <p:cNvPr id="8" name="Text Placeholder 7">
+            <a:extLst>
+              <a:ext uri="{FF2B5EF4-FFF2-40B4-BE49-F238E27FC236}">
+                <a16:creationId xmlns:a16="http://schemas.microsoft.com/office/drawing/2014/main" id="{D00799EC-D46E-16AA-0F7B-38A77CB35D53}"/>
+              </a:ext>
+            </a:extLst>
+          </p:cNvPr>
+          <p:cNvSpPr>
+            <a:spLocks noGrp="1"/>
+          </p:cNvSpPr>
+          <p:nvPr>
+            <p:ph type="body" sz="quarter" idx="13"/>
+          </p:nvPr>
+        </p:nvSpPr>
+        <p:spPr/>
+        <p:txBody>
+          <a:bodyPr/>
+          <a:lstStyle/>
+          <a:p>
             <a:r>
               <a:rPr lang="en-US" dirty="0"/>
-              <a:t>Ship the first version of </a:t>
-            </a:r>
-            <a:r>
-              <a:rPr lang="en-US" dirty="0" err="1"/>
-              <a:t>WanderAI</a:t>
-            </a:r>
-            <a:r>
-              <a:rPr lang="en-US" dirty="0"/>
-              <a:t>!</a:t>
-            </a:r>
-          </a:p>
-        </p:txBody>
-      </p:sp>
+              <a:t>Master the Foundations – What makes an AI agent tick?</a:t>
+            </a:r>
+          </a:p>
+        </p:txBody>
+      </p:sp>
+      <p:sp>
+        <p:nvSpPr>
+          <p:cNvPr id="4" name="TextBox 3">
+            <a:extLst>
+              <a:ext uri="{FF2B5EF4-FFF2-40B4-BE49-F238E27FC236}">
+                <a16:creationId xmlns:a16="http://schemas.microsoft.com/office/drawing/2014/main" id="{7638A8DB-B131-6AA5-A921-2095564E2839}"/>
+              </a:ext>
+            </a:extLst>
+          </p:cNvPr>
+          <p:cNvSpPr txBox="1"/>
+          <p:nvPr/>
+        </p:nvSpPr>
+        <p:spPr>
+          <a:xfrm>
+            <a:off x="5034987" y="1307939"/>
+            <a:ext cx="184731" cy="369332"/>
+          </a:xfrm>
+          <a:prstGeom prst="rect">
+            <a:avLst/>
+          </a:prstGeom>
+          <a:noFill/>
+        </p:spPr>
+        <p:txBody>
+          <a:bodyPr wrap="none" rtlCol="0">
+            <a:spAutoFit/>
+          </a:bodyPr>
+          <a:lstStyle/>
+          <a:p>
+            <a:endParaRPr lang="en-US" dirty="0"/>
+          </a:p>
+        </p:txBody>
+      </p:sp>
+      <p:sp>
+        <p:nvSpPr>
+          <p:cNvPr id="6" name="TextBox 5">
+            <a:extLst>
+              <a:ext uri="{FF2B5EF4-FFF2-40B4-BE49-F238E27FC236}">
+                <a16:creationId xmlns:a16="http://schemas.microsoft.com/office/drawing/2014/main" id="{F568E194-C506-7F9A-A7BF-6E9823F87A69}"/>
+              </a:ext>
+            </a:extLst>
+          </p:cNvPr>
+          <p:cNvSpPr txBox="1"/>
+          <p:nvPr/>
+        </p:nvSpPr>
+        <p:spPr>
+          <a:xfrm>
+            <a:off x="5775767" y="1088020"/>
+            <a:ext cx="184731" cy="369332"/>
+          </a:xfrm>
+          <a:prstGeom prst="rect">
+            <a:avLst/>
+          </a:prstGeom>
+          <a:noFill/>
+        </p:spPr>
+        <p:txBody>
+          <a:bodyPr wrap="none" rtlCol="0">
+            <a:spAutoFit/>
+          </a:bodyPr>
+          <a:lstStyle/>
+          <a:p>
+            <a:endParaRPr lang="en-US" dirty="0"/>
+          </a:p>
+        </p:txBody>
+      </p:sp>
+      <p:sp>
+        <p:nvSpPr>
+          <p:cNvPr id="7" name="TextBox 6">
+            <a:extLst>
+              <a:ext uri="{FF2B5EF4-FFF2-40B4-BE49-F238E27FC236}">
+                <a16:creationId xmlns:a16="http://schemas.microsoft.com/office/drawing/2014/main" id="{1A428910-8F2F-3893-16A1-E493044F3282}"/>
+              </a:ext>
+            </a:extLst>
+          </p:cNvPr>
+          <p:cNvSpPr txBox="1"/>
+          <p:nvPr/>
+        </p:nvSpPr>
+        <p:spPr>
+          <a:xfrm>
+            <a:off x="6111433" y="1157468"/>
+            <a:ext cx="184731" cy="369332"/>
+          </a:xfrm>
+          <a:prstGeom prst="rect">
+            <a:avLst/>
+          </a:prstGeom>
+          <a:noFill/>
+        </p:spPr>
+        <p:txBody>
+          <a:bodyPr wrap="none" rtlCol="0">
+            <a:spAutoFit/>
+          </a:bodyPr>
+          <a:lstStyle/>
+          <a:p>
+            <a:endParaRPr lang="en-US" dirty="0"/>
+          </a:p>
+        </p:txBody>
+      </p:sp>
+      <p:pic>
+        <p:nvPicPr>
+          <p:cNvPr id="10" name="Picture 9" descr="QR Code">
+            <a:extLst>
+              <a:ext uri="{FF2B5EF4-FFF2-40B4-BE49-F238E27FC236}">
+                <a16:creationId xmlns:a16="http://schemas.microsoft.com/office/drawing/2014/main" id="{0E20EF2B-F5A4-EEC2-FB08-4EF7BAB29450}"/>
+              </a:ext>
+            </a:extLst>
+          </p:cNvPr>
+          <p:cNvPicPr>
+            <a:picLocks noChangeAspect="1"/>
+          </p:cNvPicPr>
+          <p:nvPr/>
+        </p:nvPicPr>
+        <p:blipFill>
+          <a:blip r:embed="rId3"/>
+          <a:stretch>
+            <a:fillRect/>
+          </a:stretch>
+        </p:blipFill>
+        <p:spPr>
+          <a:xfrm>
+            <a:off x="4283075" y="2018258"/>
+            <a:ext cx="3625850" cy="3625850"/>
+          </a:xfrm>
+          <a:prstGeom prst="rect">
+            <a:avLst/>
+          </a:prstGeom>
+          <a:ln w="76200">
+            <a:solidFill>
+              <a:schemeClr val="tx1"/>
+            </a:solidFill>
+          </a:ln>
+        </p:spPr>
+      </p:pic>
     </p:spTree>
     <p:extLst>
       <p:ext uri="{BB962C8B-B14F-4D97-AF65-F5344CB8AC3E}">
-        <p14:creationId xmlns:p14="http://schemas.microsoft.com/office/powerpoint/2010/main" val="1994886360"/>
+        <p14:creationId xmlns:p14="http://schemas.microsoft.com/office/powerpoint/2010/main" val="1941044123"/>
       </p:ext>
     </p:extLst>
   </p:cSld>
@@ -15262,7 +15863,7 @@
         <p:cNvPr id="1" name="">
           <a:extLst>
             <a:ext uri="{FF2B5EF4-FFF2-40B4-BE49-F238E27FC236}">
-              <a16:creationId xmlns:a16="http://schemas.microsoft.com/office/drawing/2014/main" id="{23C0D43E-7A5A-3A63-4683-DA58769BA974}"/>
+              <a16:creationId xmlns:a16="http://schemas.microsoft.com/office/drawing/2014/main" id="{25712C6D-4F42-BAEB-2EFA-7C14789A488F}"/>
             </a:ext>
           </a:extLst>
         </p:cNvPr>
@@ -15279,18 +15880,53 @@
       </p:grpSpPr>
       <p:sp>
         <p:nvSpPr>
-          <p:cNvPr id="3" name="Content Placeholder 2">
-            <a:extLst>
-              <a:ext uri="{FF2B5EF4-FFF2-40B4-BE49-F238E27FC236}">
-                <a16:creationId xmlns:a16="http://schemas.microsoft.com/office/drawing/2014/main" id="{3A79DB28-B093-94A7-B8B1-60EF8DF01951}"/>
-              </a:ext>
-            </a:extLst>
-          </p:cNvPr>
-          <p:cNvSpPr>
-            <a:spLocks noGrp="1"/>
-          </p:cNvSpPr>
-          <p:nvPr>
-            <p:ph idx="1"/>
+          <p:cNvPr id="2" name="Title 1">
+            <a:extLst>
+              <a:ext uri="{FF2B5EF4-FFF2-40B4-BE49-F238E27FC236}">
+                <a16:creationId xmlns:a16="http://schemas.microsoft.com/office/drawing/2014/main" id="{D1F0412C-C462-19AF-6F33-CBE9E1B120B0}"/>
+              </a:ext>
+            </a:extLst>
+          </p:cNvPr>
+          <p:cNvSpPr>
+            <a:spLocks noGrp="1"/>
+          </p:cNvSpPr>
+          <p:nvPr>
+            <p:ph type="title"/>
+          </p:nvPr>
+        </p:nvSpPr>
+        <p:spPr/>
+        <p:txBody>
+          <a:bodyPr lIns="90000" anchor="t" anchorCtr="0"/>
+          <a:lstStyle/>
+          <a:p>
+            <a:r>
+              <a:rPr lang="en-US" dirty="0"/>
+              <a:t>Challenge 2</a:t>
+            </a:r>
+            <a:br>
+              <a:rPr lang="en-US" dirty="0"/>
+            </a:br>
+            <a:r>
+              <a:rPr lang="en-US" dirty="0"/>
+              <a:t>- Build Your MVP</a:t>
+            </a:r>
+          </a:p>
+        </p:txBody>
+      </p:sp>
+      <p:sp>
+        <p:nvSpPr>
+          <p:cNvPr id="3" name="Text Placeholder 2">
+            <a:extLst>
+              <a:ext uri="{FF2B5EF4-FFF2-40B4-BE49-F238E27FC236}">
+                <a16:creationId xmlns:a16="http://schemas.microsoft.com/office/drawing/2014/main" id="{0726EB30-B8F0-B4D8-31BD-EFB7D114705F}"/>
+              </a:ext>
+            </a:extLst>
+          </p:cNvPr>
+          <p:cNvSpPr>
+            <a:spLocks noGrp="1"/>
+          </p:cNvSpPr>
+          <p:nvPr>
+            <p:ph type="body" idx="1"/>
           </p:nvPr>
         </p:nvSpPr>
         <p:spPr/>
@@ -15300,144 +15936,26 @@
           </a:bodyPr>
           <a:lstStyle/>
           <a:p>
-            <a:pPr marL="0" indent="0">
-              <a:buNone/>
-            </a:pPr>
-            <a:r>
-              <a:rPr lang="en-US" dirty="0">
-                <a:latin typeface="Segoe UI" panose="020B0502040204020203" pitchFamily="34" charset="0"/>
-                <a:cs typeface="Segoe UI" panose="020B0502040204020203" pitchFamily="34" charset="0"/>
-              </a:rPr>
-              <a:t>It's time to build the first version of </a:t>
-            </a:r>
-            <a:r>
-              <a:rPr lang="en-US" dirty="0" err="1">
-                <a:latin typeface="Segoe UI" panose="020B0502040204020203" pitchFamily="34" charset="0"/>
-                <a:cs typeface="Segoe UI" panose="020B0502040204020203" pitchFamily="34" charset="0"/>
-              </a:rPr>
-              <a:t>WanderAI's</a:t>
-            </a:r>
-            <a:r>
-              <a:rPr lang="en-US" dirty="0">
-                <a:latin typeface="Segoe UI" panose="020B0502040204020203" pitchFamily="34" charset="0"/>
-                <a:cs typeface="Segoe UI" panose="020B0502040204020203" pitchFamily="34" charset="0"/>
-              </a:rPr>
-              <a:t> Travel Planner service! In this challenge, you will create a Flask web application that leverages the Microsoft Agent Framework to generate personalized travel itineraries.</a:t>
-            </a:r>
-          </a:p>
-          <a:p>
-            <a:pPr marL="0" indent="0">
-              <a:buNone/>
-            </a:pPr>
-            <a:endParaRPr lang="en-US" dirty="0">
-              <a:latin typeface="Segoe UI" panose="020B0502040204020203" pitchFamily="34" charset="0"/>
-              <a:cs typeface="Segoe UI" panose="020B0502040204020203" pitchFamily="34" charset="0"/>
-            </a:endParaRPr>
-          </a:p>
-          <a:p>
-            <a:pPr marL="0" indent="0">
-              <a:buNone/>
-            </a:pPr>
-            <a:r>
-              <a:rPr lang="en-US" dirty="0">
-                <a:latin typeface="Segoe UI" panose="020B0502040204020203" pitchFamily="34" charset="0"/>
-                <a:cs typeface="Segoe UI" panose="020B0502040204020203" pitchFamily="34" charset="0"/>
-              </a:rPr>
-              <a:t>Your application will accept user travel preferences through a web form and use an AI agent to create beautiful, customized trip plans. The agent will have access to tools that provide real-time information like weather data and current date/time.</a:t>
-            </a:r>
-          </a:p>
-        </p:txBody>
-      </p:sp>
-      <p:sp>
-        <p:nvSpPr>
-          <p:cNvPr id="4" name="Text Placeholder 3">
-            <a:extLst>
-              <a:ext uri="{FF2B5EF4-FFF2-40B4-BE49-F238E27FC236}">
-                <a16:creationId xmlns:a16="http://schemas.microsoft.com/office/drawing/2014/main" id="{4397DB4C-AE02-1957-0E69-B8C672199F8F}"/>
-              </a:ext>
-            </a:extLst>
-          </p:cNvPr>
-          <p:cNvSpPr>
-            <a:spLocks noGrp="1"/>
-          </p:cNvSpPr>
-          <p:nvPr>
-            <p:ph type="body" sz="quarter" idx="13"/>
-          </p:nvPr>
-        </p:nvSpPr>
-        <p:spPr/>
-        <p:txBody>
-          <a:bodyPr>
-            <a:normAutofit/>
-          </a:bodyPr>
-          <a:lstStyle/>
-          <a:p>
-            <a:r>
-              <a:rPr lang="en-US" sz="3200" b="1" dirty="0">
-                <a:solidFill>
-                  <a:srgbClr val="7030A0"/>
-                </a:solidFill>
-                <a:latin typeface="Segoe UI" panose="020B0502040204020203" pitchFamily="34" charset="0"/>
-                <a:cs typeface="Segoe UI" panose="020B0502040204020203" pitchFamily="34" charset="0"/>
-              </a:rPr>
-              <a:t>Build Your MVP - Ship the first version of </a:t>
-            </a:r>
-            <a:r>
-              <a:rPr lang="en-US" sz="3200" b="1" dirty="0" err="1">
-                <a:solidFill>
-                  <a:srgbClr val="7030A0"/>
-                </a:solidFill>
-                <a:latin typeface="Segoe UI" panose="020B0502040204020203" pitchFamily="34" charset="0"/>
-                <a:cs typeface="Segoe UI" panose="020B0502040204020203" pitchFamily="34" charset="0"/>
-              </a:rPr>
+            <a:pPr algn="ctr"/>
+            <a:r>
+              <a:rPr lang="en-US" dirty="0"/>
+              <a:t>Ship the first version of </a:t>
+            </a:r>
+            <a:r>
+              <a:rPr lang="en-US" dirty="0" err="1"/>
               <a:t>WanderAI</a:t>
             </a:r>
             <a:r>
-              <a:rPr lang="en-US" sz="3200" b="1" dirty="0">
-                <a:solidFill>
-                  <a:srgbClr val="7030A0"/>
-                </a:solidFill>
-                <a:latin typeface="Segoe UI" panose="020B0502040204020203" pitchFamily="34" charset="0"/>
-                <a:cs typeface="Segoe UI" panose="020B0502040204020203" pitchFamily="34" charset="0"/>
-              </a:rPr>
+              <a:rPr lang="en-US" dirty="0"/>
               <a:t>!</a:t>
             </a:r>
-            <a:endParaRPr lang="en-US" dirty="0"/>
-          </a:p>
-        </p:txBody>
-      </p:sp>
-      <p:sp>
-        <p:nvSpPr>
-          <p:cNvPr id="6" name="Title 5">
-            <a:extLst>
-              <a:ext uri="{FF2B5EF4-FFF2-40B4-BE49-F238E27FC236}">
-                <a16:creationId xmlns:a16="http://schemas.microsoft.com/office/drawing/2014/main" id="{B6E493CF-4088-D4E5-DF71-E2186C7A7D2C}"/>
-              </a:ext>
-            </a:extLst>
-          </p:cNvPr>
-          <p:cNvSpPr>
-            <a:spLocks noGrp="1"/>
-          </p:cNvSpPr>
-          <p:nvPr>
-            <p:ph type="title"/>
-          </p:nvPr>
-        </p:nvSpPr>
-        <p:spPr/>
-        <p:txBody>
-          <a:bodyPr/>
-          <a:lstStyle/>
-          <a:p>
-            <a:r>
-              <a:rPr lang="en-GB" dirty="0"/>
-              <a:t>Challenge #2</a:t>
-            </a:r>
-            <a:endParaRPr lang="en-DE" dirty="0"/>
           </a:p>
         </p:txBody>
       </p:sp>
     </p:spTree>
     <p:extLst>
       <p:ext uri="{BB962C8B-B14F-4D97-AF65-F5344CB8AC3E}">
-        <p14:creationId xmlns:p14="http://schemas.microsoft.com/office/powerpoint/2010/main" val="2192518200"/>
+        <p14:creationId xmlns:p14="http://schemas.microsoft.com/office/powerpoint/2010/main" val="1994886360"/>
       </p:ext>
     </p:extLst>
   </p:cSld>
@@ -16265,15 +16783,6 @@
 </file>
 
 <file path=customXml/item1.xml><?xml version="1.0" encoding="utf-8"?>
-<?mso-contentType ?>
-<FormTemplates xmlns="http://schemas.microsoft.com/sharepoint/v3/contenttype/forms">
-  <Display>DocumentLibraryForm</Display>
-  <Edit>DocumentLibraryForm</Edit>
-  <New>DocumentLibraryForm</New>
-</FormTemplates>
-</file>
-
-<file path=customXml/item2.xml><?xml version="1.0" encoding="utf-8"?>
 <p:properties xmlns:p="http://schemas.microsoft.com/office/2006/metadata/properties" xmlns:xsi="http://www.w3.org/2001/XMLSchema-instance" xmlns:pc="http://schemas.microsoft.com/office/infopath/2007/PartnerControls">
   <documentManagement>
     <_ip_UnifiedCompliancePolicyUIAction xmlns="http://schemas.microsoft.com/sharepoint/v3" xsi:nil="true"/>
@@ -16285,6 +16794,15 @@
     </lcf76f155ced4ddcb4097134ff3c332f>
   </documentManagement>
 </p:properties>
+</file>
+
+<file path=customXml/item2.xml><?xml version="1.0" encoding="utf-8"?>
+<?mso-contentType ?>
+<FormTemplates xmlns="http://schemas.microsoft.com/sharepoint/v3/contenttype/forms">
+  <Display>DocumentLibraryForm</Display>
+  <Edit>DocumentLibraryForm</Edit>
+  <New>DocumentLibraryForm</New>
+</FormTemplates>
 </file>
 
 <file path=customXml/item3.xml><?xml version="1.0" encoding="utf-8"?>
@@ -16561,14 +17079,6 @@
 </file>
 
 <file path=customXml/itemProps1.xml><?xml version="1.0" encoding="utf-8"?>
-<ds:datastoreItem xmlns:ds="http://schemas.openxmlformats.org/officeDocument/2006/customXml" ds:itemID="{FA84066F-CF25-477A-816A-71B1599BA426}">
-  <ds:schemaRefs>
-    <ds:schemaRef ds:uri="http://schemas.microsoft.com/sharepoint/v3/contenttype/forms"/>
-  </ds:schemaRefs>
-</ds:datastoreItem>
-</file>
-
-<file path=customXml/itemProps2.xml><?xml version="1.0" encoding="utf-8"?>
 <ds:datastoreItem xmlns:ds="http://schemas.openxmlformats.org/officeDocument/2006/customXml" ds:itemID="{FE1AEC35-FA48-4D92-B146-8AAF6D580B36}">
   <ds:schemaRefs>
     <ds:schemaRef ds:uri="http://schemas.microsoft.com/office/2006/documentManagement/types"/>
@@ -16583,6 +17093,14 @@
     <ds:schemaRef ds:uri="d5681aaf-e75d-4680-b6a5-67eaf1333073"/>
     <ds:schemaRef ds:uri="http://schemas.microsoft.com/sharepoint/v3"/>
     <ds:schemaRef ds:uri="http://purl.org/dc/elements/1.1/"/>
+  </ds:schemaRefs>
+</ds:datastoreItem>
+</file>
+
+<file path=customXml/itemProps2.xml><?xml version="1.0" encoding="utf-8"?>
+<ds:datastoreItem xmlns:ds="http://schemas.openxmlformats.org/officeDocument/2006/customXml" ds:itemID="{FA84066F-CF25-477A-816A-71B1599BA426}">
+  <ds:schemaRefs>
+    <ds:schemaRef ds:uri="http://schemas.microsoft.com/sharepoint/v3/contenttype/forms"/>
   </ds:schemaRefs>
 </ds:datastoreItem>
 </file>

</xml_diff>